<commit_message>
docs(submission): pitch deck v3
</commit_message>
<xml_diff>
--- a/submission/deck/sitewhy-deck.pptx
+++ b/submission/deck/sitewhy-deck.pptx
@@ -9311,15 +9311,15 @@
         </p:nvGraphicFramePr>
         <p:xfrm>
           <a:off x="304800" y="1524000"/>
-          <a:ext cx="11582400" cy="2637790"/>
+          <a:ext cx="11582400" cy="2332355"/>
         </p:xfrm>
         <a:graphic>
           <a:graphicData uri="http://schemas.openxmlformats.org/drawingml/2006/table">
             <a:tbl>
               <a:tblPr/>
               <a:tblGrid>
-                <a:gridCol w="1137557"/>
-                <a:gridCol w="10444843"/>
+                <a:gridCol w="843751"/>
+                <a:gridCol w="10738649"/>
               </a:tblGrid>
               <a:tr h="354965">
                 <a:tc>
@@ -9429,7 +9429,7 @@
                   </a:tcPr>
                 </a:tc>
               </a:tr>
-              <a:tr h="456565">
+              <a:tr h="354965">
                 <a:tc>
                   <a:txBody>
                     <a:bodyPr/>
@@ -9488,7 +9488,7 @@
                           <a:ea typeface="Pretendard" pitchFamily="34" charset="-122"/>
                           <a:cs typeface="Pretendard" pitchFamily="34" charset="-120"/>
                         </a:rPr>
-                        <a:t>FastAPI and uvicorn; SAMPLE_MODE serves the recorded showcase reports</a:t>
+                        <a:t>FastAPI and uvicorn; SAMPLE_MODE runs the real agents on cached model responses, sources and geocodes, no keys, Zetaris or Nightshift needed</a:t>
                       </a:r>
                       <a:endParaRPr lang="en-US" sz="1100" dirty="0">
                         <a:latin typeface="Pretendard" charset="0"/>
@@ -9513,7 +9513,7 @@
                   </a:tcPr>
                 </a:tc>
               </a:tr>
-              <a:tr h="456565">
+              <a:tr h="354965">
                 <a:tc>
                   <a:txBody>
                     <a:bodyPr/>
@@ -9597,7 +9597,7 @@
                   </a:tcPr>
                 </a:tc>
               </a:tr>
-              <a:tr h="456565">
+              <a:tr h="557530">
                 <a:tc>
                   <a:txBody>
                     <a:bodyPr/>
@@ -9615,7 +9615,28 @@
                           <a:ea typeface="Pretendard" pitchFamily="34" charset="-122"/>
                           <a:cs typeface="Pretendard" pitchFamily="34" charset="-120"/>
                         </a:rPr>
-                        <a:t>AI provider</a:t>
+                        <a:t>AI</a:t>
+                      </a:r>
+                      <a:endParaRPr lang="en-US" sz="1100" dirty="0">
+                        <a:latin typeface="Pretendard" charset="0"/>
+                        <a:ea typeface="Pretendard" charset="0"/>
+                        <a:cs typeface="Pretendard" charset="0"/>
+                      </a:endParaRPr>
+                    </a:p>
+                    <a:p>
+                      <a:pPr algn="l" indent="0" marL="0">
+                        <a:buNone/>
+                      </a:pPr>
+                      <a:r>
+                        <a:rPr lang="en-US" sz="1100" dirty="0">
+                          <a:solidFill>
+                            <a:srgbClr val="15131A"/>
+                          </a:solidFill>
+                          <a:latin typeface="Pretendard" pitchFamily="34" charset="0"/>
+                          <a:ea typeface="Pretendard" pitchFamily="34" charset="-122"/>
+                          <a:cs typeface="Pretendard" pitchFamily="34" charset="-120"/>
+                        </a:rPr>
+                        <a:t>provider</a:t>
                       </a:r>
                       <a:endParaRPr lang="en-US" sz="1100" dirty="0">
                         <a:latin typeface="Pretendard" charset="0"/>
@@ -9681,7 +9702,7 @@
                   </a:tcPr>
                 </a:tc>
               </a:tr>
-              <a:tr h="456565">
+              <a:tr h="354965">
                 <a:tc>
                   <a:txBody>
                     <a:bodyPr/>
@@ -9765,7 +9786,7 @@
                   </a:tcPr>
                 </a:tc>
               </a:tr>
-              <a:tr h="456565">
+              <a:tr h="354965">
                 <a:tc>
                   <a:txBody>
                     <a:bodyPr/>
@@ -9873,7 +9894,7 @@
         </p:nvSpPr>
         <p:spPr>
           <a:xfrm>
-            <a:off x="304800" y="4237990"/>
+            <a:off x="304800" y="3932555"/>
             <a:ext cx="11582400" cy="181610"/>
           </a:xfrm>
           <a:prstGeom prst="rect">
@@ -9915,7 +9936,7 @@
         </p:nvSpPr>
         <p:spPr>
           <a:xfrm>
-            <a:off x="304800" y="5030788"/>
+            <a:off x="304800" y="4420553"/>
             <a:ext cx="50800" cy="50800"/>
           </a:xfrm>
           <a:prstGeom prst="rect">
@@ -9935,8 +9956,8 @@
         </p:nvSpPr>
         <p:spPr>
           <a:xfrm>
-            <a:off x="482600" y="4953000"/>
-            <a:ext cx="5461000" cy="412750"/>
+            <a:off x="482600" y="4342765"/>
+            <a:ext cx="8432800" cy="412750"/>
           </a:xfrm>
           <a:prstGeom prst="rect">
             <a:avLst/>
@@ -9963,7 +9984,7 @@
                 <a:ea typeface="Pretendard" pitchFamily="34" charset="-122"/>
                 <a:cs typeface="Pretendard" pitchFamily="34" charset="-120"/>
               </a:rPr>
-              <a:t>One run at a time; a run past its 5-minute deadline returns a</a:t>
+              <a:t>One run at a time; a run past its 5-minute deadline returns a partial needs_confirmation report</a:t>
             </a:r>
             <a:endParaRPr lang="en-US" sz="1300" dirty="0"/>
           </a:p>
@@ -9983,7 +10004,7 @@
                 <a:ea typeface="Pretendard" pitchFamily="34" charset="-122"/>
                 <a:cs typeface="Pretendard" pitchFamily="34" charset="-120"/>
               </a:rPr>
-              <a:t>partial needs_confirmation report instead of hanging.</a:t>
+              <a:t>instead of hanging.</a:t>
             </a:r>
             <a:endParaRPr lang="en-US" sz="1300" dirty="0"/>
           </a:p>
@@ -9997,7 +10018,7 @@
         </p:nvSpPr>
         <p:spPr>
           <a:xfrm>
-            <a:off x="6248400" y="5030788"/>
+            <a:off x="304800" y="4909503"/>
             <a:ext cx="50800" cy="50800"/>
           </a:xfrm>
           <a:prstGeom prst="rect">
@@ -10017,8 +10038,8 @@
         </p:nvSpPr>
         <p:spPr>
           <a:xfrm>
-            <a:off x="6426200" y="4953000"/>
-            <a:ext cx="5461000" cy="206375"/>
+            <a:off x="482600" y="4831715"/>
+            <a:ext cx="8432800" cy="206375"/>
           </a:xfrm>
           <a:prstGeom prst="rect">
             <a:avLst/>
@@ -10053,7 +10074,89 @@
       </p:sp>
       <p:sp>
         <p:nvSpPr>
-          <p:cNvPr id="10" name="Text 7"/>
+          <p:cNvPr id="10" name="Shape 7"/>
+          <p:cNvSpPr/>
+          <p:nvPr/>
+        </p:nvSpPr>
+        <p:spPr>
+          <a:xfrm>
+            <a:off x="304800" y="5192078"/>
+            <a:ext cx="50800" cy="50800"/>
+          </a:xfrm>
+          <a:prstGeom prst="rect">
+            <a:avLst/>
+          </a:prstGeom>
+          <a:solidFill>
+            <a:srgbClr val="C8361A"/>
+          </a:solidFill>
+          <a:ln/>
+        </p:spPr>
+      </p:sp>
+      <p:sp>
+        <p:nvSpPr>
+          <p:cNvPr id="11" name="Text 8"/>
+          <p:cNvSpPr/>
+          <p:nvPr/>
+        </p:nvSpPr>
+        <p:spPr>
+          <a:xfrm>
+            <a:off x="482600" y="5114290"/>
+            <a:ext cx="8432800" cy="412750"/>
+          </a:xfrm>
+          <a:prstGeom prst="rect">
+            <a:avLst/>
+          </a:prstGeom>
+          <a:noFill/>
+          <a:ln/>
+        </p:spPr>
+        <p:txBody>
+          <a:bodyPr wrap="square" lIns="0" tIns="0" rIns="0" bIns="0" rtlCol="0" anchor="t"/>
+          <a:lstStyle/>
+          <a:p>
+            <a:pPr algn="l" indent="0" marL="0">
+              <a:lnSpc>
+                <a:spcPts val="1630"/>
+              </a:lnSpc>
+              <a:buNone/>
+            </a:pPr>
+            <a:r>
+              <a:rPr lang="en-US" sz="1300" dirty="0">
+                <a:solidFill>
+                  <a:srgbClr val="15131A"/>
+                </a:solidFill>
+                <a:latin typeface="Pretendard" pitchFamily="34" charset="0"/>
+                <a:ea typeface="Pretendard" pitchFamily="34" charset="-122"/>
+                <a:cs typeface="Pretendard" pitchFamily="34" charset="-120"/>
+              </a:rPr>
+              <a:t>Programmatic entry: python run.py --input input_examples/&lt;site&gt;.json --sample, with per-event</a:t>
+            </a:r>
+            <a:endParaRPr lang="en-US" sz="1300" dirty="0"/>
+          </a:p>
+          <a:p>
+            <a:pPr algn="l" indent="0" marL="0">
+              <a:lnSpc>
+                <a:spcPts val="1630"/>
+              </a:lnSpc>
+              <a:buNone/>
+            </a:pPr>
+            <a:r>
+              <a:rPr lang="en-US" sz="1300" dirty="0">
+                <a:solidFill>
+                  <a:srgbClr val="15131A"/>
+                </a:solidFill>
+                <a:latin typeface="Pretendard" pitchFamily="34" charset="0"/>
+                <a:ea typeface="Pretendard" pitchFamily="34" charset="-122"/>
+                <a:cs typeface="Pretendard" pitchFamily="34" charset="-120"/>
+              </a:rPr>
+              <a:t>traces in logs/*.jsonl.</a:t>
+            </a:r>
+            <a:endParaRPr lang="en-US" sz="1300" dirty="0"/>
+          </a:p>
+        </p:txBody>
+      </p:sp>
+      <p:sp>
+        <p:nvSpPr>
+          <p:cNvPr id="12" name="Text 9"/>
           <p:cNvSpPr/>
           <p:nvPr/>
         </p:nvSpPr>
@@ -10087,7 +10190,7 @@
                 <a:ea typeface="Pretendard" pitchFamily="34" charset="-122"/>
                 <a:cs typeface="Pretendard" pitchFamily="34" charset="-120"/>
               </a:rPr>
-              <a:t>Source: README; app/llm.py STEP_MODELS; app/data.py</a:t>
+              <a:t>Source: README; app/llm.py STEP_MODELS; app/data.py; run.py</a:t>
             </a:r>
             <a:endParaRPr lang="en-US" sz="900" dirty="0"/>
           </a:p>
@@ -10095,7 +10198,7 @@
       </p:sp>
       <p:sp>
         <p:nvSpPr>
-          <p:cNvPr id="11" name="title@top-rule"/>
+          <p:cNvPr id="13" name="title@top-rule"/>
           <p:cNvSpPr/>
           <p:nvPr/>
         </p:nvSpPr>
@@ -12333,7 +12436,7 @@
                           <a:ea typeface="Pretendard" pitchFamily="34" charset="-122"/>
                           <a:cs typeface="Pretendard" pitchFamily="34" charset="-120"/>
                         </a:rPr>
-                        <a:t>169 passed</a:t>
+                        <a:t>171 passed</a:t>
                       </a:r>
                       <a:endParaRPr lang="en-US" sz="1100" dirty="0">
                         <a:latin typeface="Pretendard" charset="0"/>
@@ -12602,7 +12705,7 @@
         </p:nvSpPr>
         <p:spPr>
           <a:xfrm>
-            <a:off x="304800" y="4232592"/>
+            <a:off x="304800" y="4080193"/>
             <a:ext cx="50800" cy="50800"/>
           </a:xfrm>
           <a:prstGeom prst="rect">
@@ -12622,8 +12725,8 @@
         </p:nvSpPr>
         <p:spPr>
           <a:xfrm>
-            <a:off x="482600" y="4154805"/>
-            <a:ext cx="5461000" cy="412750"/>
+            <a:off x="482600" y="4002405"/>
+            <a:ext cx="8432800" cy="412750"/>
           </a:xfrm>
           <a:prstGeom prst="rect">
             <a:avLst/>
@@ -12650,7 +12753,7 @@
                 <a:ea typeface="Pretendard" pitchFamily="34" charset="-122"/>
                 <a:cs typeface="Pretendard" pitchFamily="34" charset="-120"/>
               </a:rPr>
-              <a:t>Markovian saved 0 tokens on current sources; the engine and its</a:t>
+              <a:t>Markovian saved 0 tokens on current sources; the engine and its accounting are implemented</a:t>
             </a:r>
             <a:endParaRPr lang="en-US" sz="1300" dirty="0"/>
           </a:p>
@@ -12670,7 +12773,7 @@
                 <a:ea typeface="Pretendard" pitchFamily="34" charset="-122"/>
                 <a:cs typeface="Pretendard" pitchFamily="34" charset="-120"/>
               </a:rPr>
-              <a:t>accounting are implemented and tested.</a:t>
+              <a:t>and tested.</a:t>
             </a:r>
             <a:endParaRPr lang="en-US" sz="1300" dirty="0"/>
           </a:p>
@@ -12684,7 +12787,7 @@
         </p:nvSpPr>
         <p:spPr>
           <a:xfrm>
-            <a:off x="304800" y="4797742"/>
+            <a:off x="304800" y="4569142"/>
             <a:ext cx="50800" cy="50800"/>
           </a:xfrm>
           <a:prstGeom prst="rect">
@@ -12704,8 +12807,8 @@
         </p:nvSpPr>
         <p:spPr>
           <a:xfrm>
-            <a:off x="482600" y="4719955"/>
-            <a:ext cx="5461000" cy="412750"/>
+            <a:off x="482600" y="4491355"/>
+            <a:ext cx="8432800" cy="206375"/>
           </a:xfrm>
           <a:prstGeom prst="rect">
             <a:avLst/>
@@ -12732,30 +12835,10 @@
                 <a:ea typeface="Pretendard" pitchFamily="34" charset="-122"/>
                 <a:cs typeface="Pretendard" pitchFamily="34" charset="-120"/>
               </a:rPr>
-              <a:t>Seed rules are curated with runtime-verified quotes; autonomous</a:t>
+              <a:t>Seed rules are curated with runtime-verified quotes; autonomous rule discovery is roadmap.</a:t>
             </a:r>
             <a:endParaRPr lang="en-US" sz="1300" dirty="0"/>
           </a:p>
-          <a:p>
-            <a:pPr algn="l" indent="0" marL="0">
-              <a:lnSpc>
-                <a:spcPts val="1630"/>
-              </a:lnSpc>
-              <a:buNone/>
-            </a:pPr>
-            <a:r>
-              <a:rPr lang="en-US" sz="1300" dirty="0">
-                <a:solidFill>
-                  <a:srgbClr val="15131A"/>
-                </a:solidFill>
-                <a:latin typeface="Pretendard" pitchFamily="34" charset="0"/>
-                <a:ea typeface="Pretendard" pitchFamily="34" charset="-122"/>
-                <a:cs typeface="Pretendard" pitchFamily="34" charset="-120"/>
-              </a:rPr>
-              <a:t>rule discovery is roadmap.</a:t>
-            </a:r>
-            <a:endParaRPr lang="en-US" sz="1300" dirty="0"/>
-          </a:p>
         </p:txBody>
       </p:sp>
       <p:sp>
@@ -12766,7 +12849,7 @@
         </p:nvSpPr>
         <p:spPr>
           <a:xfrm>
-            <a:off x="6248400" y="4232592"/>
+            <a:off x="304800" y="4851718"/>
             <a:ext cx="50800" cy="50800"/>
           </a:xfrm>
           <a:prstGeom prst="rect">
@@ -12786,8 +12869,8 @@
         </p:nvSpPr>
         <p:spPr>
           <a:xfrm>
-            <a:off x="6426200" y="4154805"/>
-            <a:ext cx="5461000" cy="412750"/>
+            <a:off x="482600" y="4773930"/>
+            <a:ext cx="8432800" cy="412750"/>
           </a:xfrm>
           <a:prstGeom prst="rect">
             <a:avLst/>
@@ -12814,7 +12897,7 @@
                 <a:ea typeface="Pretendard" pitchFamily="34" charset="-122"/>
                 <a:cs typeface="Pretendard" pitchFamily="34" charset="-120"/>
               </a:rPr>
-              <a:t>Coverage is modelled for Texas and ERCOT plus two counties; other</a:t>
+              <a:t>Coverage is modelled for Texas and ERCOT plus two counties; other states get a federal-only report</a:t>
             </a:r>
             <a:endParaRPr lang="en-US" sz="1300" dirty="0"/>
           </a:p>
@@ -12834,7 +12917,7 @@
                 <a:ea typeface="Pretendard" pitchFamily="34" charset="-122"/>
                 <a:cs typeface="Pretendard" pitchFamily="34" charset="-120"/>
               </a:rPr>
-              <a:t>states get a federal-only report with an explicit scope note.</a:t>
+              <a:t>with an explicit scope note.</a:t>
             </a:r>
             <a:endParaRPr lang="en-US" sz="1300" dirty="0"/>
           </a:p>
@@ -12842,89 +12925,7 @@
       </p:sp>
       <p:sp>
         <p:nvSpPr>
-          <p:cNvPr id="12" name="Shape 9"/>
-          <p:cNvSpPr/>
-          <p:nvPr/>
-        </p:nvSpPr>
-        <p:spPr>
-          <a:xfrm>
-            <a:off x="6248400" y="4797742"/>
-            <a:ext cx="50800" cy="50800"/>
-          </a:xfrm>
-          <a:prstGeom prst="rect">
-            <a:avLst/>
-          </a:prstGeom>
-          <a:solidFill>
-            <a:srgbClr val="C8361A"/>
-          </a:solidFill>
-          <a:ln/>
-        </p:spPr>
-      </p:sp>
-      <p:sp>
-        <p:nvSpPr>
-          <p:cNvPr id="13" name="Text 10"/>
-          <p:cNvSpPr/>
-          <p:nvPr/>
-        </p:nvSpPr>
-        <p:spPr>
-          <a:xfrm>
-            <a:off x="6426200" y="4719955"/>
-            <a:ext cx="5461000" cy="412750"/>
-          </a:xfrm>
-          <a:prstGeom prst="rect">
-            <a:avLst/>
-          </a:prstGeom>
-          <a:noFill/>
-          <a:ln/>
-        </p:spPr>
-        <p:txBody>
-          <a:bodyPr wrap="square" lIns="0" tIns="0" rIns="0" bIns="0" rtlCol="0" anchor="t"/>
-          <a:lstStyle/>
-          <a:p>
-            <a:pPr algn="l" indent="0" marL="0">
-              <a:lnSpc>
-                <a:spcPts val="1630"/>
-              </a:lnSpc>
-              <a:buNone/>
-            </a:pPr>
-            <a:r>
-              <a:rPr lang="en-US" sz="1300" dirty="0">
-                <a:solidFill>
-                  <a:srgbClr val="15131A"/>
-                </a:solidFill>
-                <a:latin typeface="Pretendard" pitchFamily="34" charset="0"/>
-                <a:ea typeface="Pretendard" pitchFamily="34" charset="-122"/>
-                <a:cs typeface="Pretendard" pitchFamily="34" charset="-120"/>
-              </a:rPr>
-              <a:t>The same pytest run shows 2 failures from in-progress</a:t>
-            </a:r>
-            <a:endParaRPr lang="en-US" sz="1300" dirty="0"/>
-          </a:p>
-          <a:p>
-            <a:pPr algn="l" indent="0" marL="0">
-              <a:lnSpc>
-                <a:spcPts val="1630"/>
-              </a:lnSpc>
-              <a:buNone/>
-            </a:pPr>
-            <a:r>
-              <a:rPr lang="en-US" sz="1300" dirty="0">
-                <a:solidFill>
-                  <a:srgbClr val="15131A"/>
-                </a:solidFill>
-                <a:latin typeface="Pretendard" pitchFamily="34" charset="0"/>
-                <a:ea typeface="Pretendard" pitchFamily="34" charset="-122"/>
-                <a:cs typeface="Pretendard" pitchFamily="34" charset="-120"/>
-              </a:rPr>
-              <a:t>sample-mode work in another lane, outside this deck.</a:t>
-            </a:r>
-            <a:endParaRPr lang="en-US" sz="1300" dirty="0"/>
-          </a:p>
-        </p:txBody>
-      </p:sp>
-      <p:sp>
-        <p:nvSpPr>
-          <p:cNvPr id="14" name="Text 11"/>
+          <p:cNvPr id="12" name="Text 9"/>
           <p:cNvSpPr/>
           <p:nvPr/>
         </p:nvSpPr>
@@ -12966,7 +12967,7 @@
       </p:sp>
       <p:sp>
         <p:nvSpPr>
-          <p:cNvPr id="15" name="title@top-rule"/>
+          <p:cNvPr id="13" name="title@top-rule"/>
           <p:cNvSpPr/>
           <p:nvPr/>
         </p:nvSpPr>

</xml_diff>

<commit_message>
docs(submission): pitch deck matches the code
</commit_message>
<xml_diff>
--- a/submission/deck/sitewhy-deck.pptx
+++ b/submission/deck/sitewhy-deck.pptx
@@ -3779,7 +3779,7 @@
         <p:spPr>
           <a:xfrm>
             <a:off x="8483600" y="2743200"/>
-            <a:ext cx="3403600" cy="1143000"/>
+            <a:ext cx="3403600" cy="1428750"/>
           </a:xfrm>
           <a:prstGeom prst="rect">
             <a:avLst/>
@@ -3843,7 +3843,7 @@
                 <a:ea typeface="Pretendard" pitchFamily="34" charset="-122"/>
                 <a:cs typeface="Pretendard" pitchFamily="34" charset="-120"/>
               </a:rPr>
-              <a:t>extraction and verification;</a:t>
+              <a:t>county extraction; code</a:t>
             </a:r>
             <a:endParaRPr lang="en-US" sz="1800" dirty="0"/>
           </a:p>
@@ -3863,6 +3863,26 @@
                 <a:ea typeface="Pretendard" pitchFamily="34" charset="-122"/>
                 <a:cs typeface="Pretendard" pitchFamily="34" charset="-120"/>
               </a:rPr>
+              <a:t>verifies quotes verbatim;</a:t>
+            </a:r>
+            <a:endParaRPr lang="en-US" sz="1800" dirty="0"/>
+          </a:p>
+          <a:p>
+            <a:pPr algn="l" indent="0" marL="0">
+              <a:lnSpc>
+                <a:spcPts val="2250"/>
+              </a:lnSpc>
+              <a:buNone/>
+            </a:pPr>
+            <a:r>
+              <a:rPr lang="en-US" sz="1800" dirty="0">
+                <a:solidFill>
+                  <a:srgbClr val="15131A"/>
+                </a:solidFill>
+                <a:latin typeface="Pretendard" pitchFamily="34" charset="0"/>
+                <a:ea typeface="Pretendard" pitchFamily="34" charset="-122"/>
+                <a:cs typeface="Pretendard" pitchFamily="34" charset="-120"/>
+              </a:rPr>
               <a:t>Ultra handles planning,</a:t>
             </a:r>
             <a:endParaRPr lang="en-US" sz="1800" dirty="0"/>
@@ -3897,7 +3917,7 @@
         </p:nvSpPr>
         <p:spPr>
           <a:xfrm>
-            <a:off x="8229600" y="4073525"/>
+            <a:off x="8229600" y="4359275"/>
             <a:ext cx="63500" cy="63500"/>
           </a:xfrm>
           <a:prstGeom prst="rect">
@@ -3917,7 +3937,7 @@
         </p:nvSpPr>
         <p:spPr>
           <a:xfrm>
-            <a:off x="8483600" y="3962400"/>
+            <a:off x="8483600" y="4248150"/>
             <a:ext cx="3403600" cy="857250"/>
           </a:xfrm>
           <a:prstGeom prst="rect">
@@ -7674,8 +7694,8 @@
         </p:nvSpPr>
         <p:spPr>
           <a:xfrm>
-            <a:off x="9220200" y="5947410"/>
-            <a:ext cx="2667000" cy="6350"/>
+            <a:off x="8229600" y="5947410"/>
+            <a:ext cx="3657600" cy="6350"/>
           </a:xfrm>
           <a:prstGeom prst="rect">
             <a:avLst/>
@@ -7702,8 +7722,8 @@
         </p:blipFill>
         <p:spPr>
           <a:xfrm>
-            <a:off x="707531" y="1524000"/>
-            <a:ext cx="7805138" cy="4390390"/>
+            <a:off x="373662" y="1524000"/>
+            <a:ext cx="7482276" cy="4208780"/>
           </a:xfrm>
           <a:prstGeom prst="rect">
             <a:avLst/>
@@ -7718,8 +7738,8 @@
         </p:nvSpPr>
         <p:spPr>
           <a:xfrm>
-            <a:off x="304800" y="5990590"/>
-            <a:ext cx="8610600" cy="181610"/>
+            <a:off x="304800" y="5808980"/>
+            <a:ext cx="7620000" cy="363220"/>
           </a:xfrm>
           <a:prstGeom prst="rect">
             <a:avLst/>
@@ -7746,10 +7766,30 @@
                 <a:ea typeface="Pretendard" pitchFamily="34" charset="-122"/>
                 <a:cs typeface="Pretendard" pitchFamily="34" charset="-120"/>
               </a:rPr>
-              <a:t>Figure 1. SiteWhy brand visual: site, grid and rule layers over the US | Source: branding/sitewhy-team.png</a:t>
+              <a:t>Figure 1. SiteWhy brand visual: site, grid and rule layers over the US |</a:t>
             </a:r>
             <a:endParaRPr lang="en-US" sz="1100" dirty="0"/>
           </a:p>
+          <a:p>
+            <a:pPr algn="l" indent="0" marL="0">
+              <a:lnSpc>
+                <a:spcPts val="1430"/>
+              </a:lnSpc>
+              <a:buNone/>
+            </a:pPr>
+            <a:r>
+              <a:rPr lang="en-US" sz="1100" dirty="0">
+                <a:solidFill>
+                  <a:srgbClr val="55525C"/>
+                </a:solidFill>
+                <a:latin typeface="Pretendard" pitchFamily="34" charset="0"/>
+                <a:ea typeface="Pretendard" pitchFamily="34" charset="-122"/>
+                <a:cs typeface="Pretendard" pitchFamily="34" charset="-120"/>
+              </a:rPr>
+              <a:t>Source: branding/sitewhy-team.png</a:t>
+            </a:r>
+            <a:endParaRPr lang="en-US" sz="1100" dirty="0"/>
+          </a:p>
         </p:txBody>
       </p:sp>
       <p:sp>
@@ -7760,7 +7800,7 @@
         </p:nvSpPr>
         <p:spPr>
           <a:xfrm>
-            <a:off x="9220200" y="1601788"/>
+            <a:off x="8229600" y="1601788"/>
             <a:ext cx="50800" cy="50800"/>
           </a:xfrm>
           <a:prstGeom prst="rect">
@@ -7780,8 +7820,8 @@
         </p:nvSpPr>
         <p:spPr>
           <a:xfrm>
-            <a:off x="9398000" y="1524000"/>
-            <a:ext cx="2489200" cy="1238250"/>
+            <a:off x="8407400" y="1524000"/>
+            <a:ext cx="3479800" cy="825500"/>
           </a:xfrm>
           <a:prstGeom prst="rect">
             <a:avLst/>
@@ -7825,7 +7865,7 @@
                 <a:ea typeface="Pretendard" pitchFamily="34" charset="-122"/>
                 <a:cs typeface="Pretendard" pitchFamily="34" charset="-120"/>
               </a:rPr>
-              <a:t> go, conditional or</a:t>
+              <a:t> go, conditional or no-go for a</a:t>
             </a:r>
             <a:endParaRPr lang="en-US" sz="1300" dirty="0"/>
           </a:p>
@@ -7845,7 +7885,7 @@
                 <a:ea typeface="Pretendard" pitchFamily="34" charset="-122"/>
                 <a:cs typeface="Pretendard" pitchFamily="34" charset="-120"/>
               </a:rPr>
-              <a:t>no-go for a US address plus</a:t>
+              <a:t>US address plus IT load, with the</a:t>
             </a:r>
             <a:endParaRPr lang="en-US" sz="1300" dirty="0"/>
           </a:p>
@@ -7865,7 +7905,7 @@
                 <a:ea typeface="Pretendard" pitchFamily="34" charset="-122"/>
                 <a:cs typeface="Pretendard" pitchFamily="34" charset="-120"/>
               </a:rPr>
-              <a:t>IT load, with the verified</a:t>
+              <a:t>verified rule text, the applicability</a:t>
             </a:r>
             <a:endParaRPr lang="en-US" sz="1300" dirty="0"/>
           </a:p>
@@ -7885,50 +7925,10 @@
                 <a:ea typeface="Pretendard" pitchFamily="34" charset="-122"/>
                 <a:cs typeface="Pretendard" pitchFamily="34" charset="-120"/>
               </a:rPr>
-              <a:t>rule text, the applicability</a:t>
+              <a:t>math, and what would change the answer.</a:t>
             </a:r>
             <a:endParaRPr lang="en-US" sz="1300" dirty="0"/>
           </a:p>
-          <a:p>
-            <a:pPr algn="l" indent="0" marL="0">
-              <a:lnSpc>
-                <a:spcPts val="1630"/>
-              </a:lnSpc>
-              <a:buNone/>
-            </a:pPr>
-            <a:r>
-              <a:rPr lang="en-US" sz="1300" dirty="0">
-                <a:solidFill>
-                  <a:srgbClr val="15131A"/>
-                </a:solidFill>
-                <a:latin typeface="Pretendard" pitchFamily="34" charset="0"/>
-                <a:ea typeface="Pretendard" pitchFamily="34" charset="-122"/>
-                <a:cs typeface="Pretendard" pitchFamily="34" charset="-120"/>
-              </a:rPr>
-              <a:t>math, and what would change</a:t>
-            </a:r>
-            <a:endParaRPr lang="en-US" sz="1300" dirty="0"/>
-          </a:p>
-          <a:p>
-            <a:pPr algn="l" indent="0" marL="0">
-              <a:lnSpc>
-                <a:spcPts val="1630"/>
-              </a:lnSpc>
-              <a:buNone/>
-            </a:pPr>
-            <a:r>
-              <a:rPr lang="en-US" sz="1300" dirty="0">
-                <a:solidFill>
-                  <a:srgbClr val="15131A"/>
-                </a:solidFill>
-                <a:latin typeface="Pretendard" pitchFamily="34" charset="0"/>
-                <a:ea typeface="Pretendard" pitchFamily="34" charset="-122"/>
-                <a:cs typeface="Pretendard" pitchFamily="34" charset="-120"/>
-              </a:rPr>
-              <a:t>the answer.</a:t>
-            </a:r>
-            <a:endParaRPr lang="en-US" sz="1300" dirty="0"/>
-          </a:p>
         </p:txBody>
       </p:sp>
       <p:sp>
@@ -7939,7 +7939,7 @@
         </p:nvSpPr>
         <p:spPr>
           <a:xfrm>
-            <a:off x="9220200" y="2916238"/>
+            <a:off x="8229600" y="2503488"/>
             <a:ext cx="50800" cy="50800"/>
           </a:xfrm>
           <a:prstGeom prst="rect">
@@ -7959,8 +7959,8 @@
         </p:nvSpPr>
         <p:spPr>
           <a:xfrm>
-            <a:off x="9398000" y="2838450"/>
-            <a:ext cx="2489200" cy="825500"/>
+            <a:off x="8407400" y="2425700"/>
+            <a:ext cx="3479800" cy="619125"/>
           </a:xfrm>
           <a:prstGeom prst="rect">
             <a:avLst/>
@@ -8004,10 +8004,50 @@
                 <a:ea typeface="Pretendard" pitchFamily="34" charset="-122"/>
                 <a:cs typeface="Pretendard" pitchFamily="34" charset="-120"/>
               </a:rPr>
-              <a:t> The Agent That Can Explain Why: every verdict traces to a quote plus arithmetic, never to a completion alone.</a:t>
+              <a:t> The Agent That Can Explain Why:</a:t>
             </a:r>
             <a:endParaRPr lang="en-US" sz="1300" dirty="0"/>
           </a:p>
+          <a:p>
+            <a:pPr algn="l" indent="0" marL="0">
+              <a:lnSpc>
+                <a:spcPts val="1630"/>
+              </a:lnSpc>
+              <a:buNone/>
+            </a:pPr>
+            <a:r>
+              <a:rPr lang="en-US" sz="1300" dirty="0">
+                <a:solidFill>
+                  <a:srgbClr val="15131A"/>
+                </a:solidFill>
+                <a:latin typeface="Pretendard" pitchFamily="34" charset="0"/>
+                <a:ea typeface="Pretendard" pitchFamily="34" charset="-122"/>
+                <a:cs typeface="Pretendard" pitchFamily="34" charset="-120"/>
+              </a:rPr>
+              <a:t>every verdict traces to a quote plus</a:t>
+            </a:r>
+            <a:endParaRPr lang="en-US" sz="1300" dirty="0"/>
+          </a:p>
+          <a:p>
+            <a:pPr algn="l" indent="0" marL="0">
+              <a:lnSpc>
+                <a:spcPts val="1630"/>
+              </a:lnSpc>
+              <a:buNone/>
+            </a:pPr>
+            <a:r>
+              <a:rPr lang="en-US" sz="1300" dirty="0">
+                <a:solidFill>
+                  <a:srgbClr val="15131A"/>
+                </a:solidFill>
+                <a:latin typeface="Pretendard" pitchFamily="34" charset="0"/>
+                <a:ea typeface="Pretendard" pitchFamily="34" charset="-122"/>
+                <a:cs typeface="Pretendard" pitchFamily="34" charset="-120"/>
+              </a:rPr>
+              <a:t>arithmetic, never to a completion alone.</a:t>
+            </a:r>
+            <a:endParaRPr lang="en-US" sz="1300" dirty="0"/>
+          </a:p>
         </p:txBody>
       </p:sp>
       <p:sp>
@@ -8018,7 +8058,7 @@
         </p:nvSpPr>
         <p:spPr>
           <a:xfrm>
-            <a:off x="9220200" y="3817938"/>
+            <a:off x="8229600" y="3198813"/>
             <a:ext cx="50800" cy="50800"/>
           </a:xfrm>
           <a:prstGeom prst="rect">
@@ -8038,8 +8078,8 @@
         </p:nvSpPr>
         <p:spPr>
           <a:xfrm>
-            <a:off x="9398000" y="3740150"/>
-            <a:ext cx="2489200" cy="1238250"/>
+            <a:off x="8407400" y="3121025"/>
+            <a:ext cx="3479800" cy="1238250"/>
           </a:xfrm>
           <a:prstGeom prst="rect">
             <a:avLst/>
@@ -8083,10 +8123,110 @@
                 <a:ea typeface="Pretendard" pitchFamily="34" charset="-122"/>
                 <a:cs typeface="Pretendard" pitchFamily="34" charset="-120"/>
               </a:rPr>
-              <a:t> federal Title V, a 1,291-entry moratorium dataset, Texas and ERCOT state and grid rules, verified county ordinances for Washington County MD and Pima County AZ.</a:t>
+              <a:t> federal Title V, a 1,291-entry</a:t>
             </a:r>
             <a:endParaRPr lang="en-US" sz="1300" dirty="0"/>
           </a:p>
+          <a:p>
+            <a:pPr algn="l" indent="0" marL="0">
+              <a:lnSpc>
+                <a:spcPts val="1630"/>
+              </a:lnSpc>
+              <a:buNone/>
+            </a:pPr>
+            <a:r>
+              <a:rPr lang="en-US" sz="1300" dirty="0">
+                <a:solidFill>
+                  <a:srgbClr val="15131A"/>
+                </a:solidFill>
+                <a:latin typeface="Pretendard" pitchFamily="34" charset="0"/>
+                <a:ea typeface="Pretendard" pitchFamily="34" charset="-122"/>
+                <a:cs typeface="Pretendard" pitchFamily="34" charset="-120"/>
+              </a:rPr>
+              <a:t>moratorium dataset, Texas and ERCOT</a:t>
+            </a:r>
+            <a:endParaRPr lang="en-US" sz="1300" dirty="0"/>
+          </a:p>
+          <a:p>
+            <a:pPr algn="l" indent="0" marL="0">
+              <a:lnSpc>
+                <a:spcPts val="1630"/>
+              </a:lnSpc>
+              <a:buNone/>
+            </a:pPr>
+            <a:r>
+              <a:rPr lang="en-US" sz="1300" dirty="0">
+                <a:solidFill>
+                  <a:srgbClr val="15131A"/>
+                </a:solidFill>
+                <a:latin typeface="Pretendard" pitchFamily="34" charset="0"/>
+                <a:ea typeface="Pretendard" pitchFamily="34" charset="-122"/>
+                <a:cs typeface="Pretendard" pitchFamily="34" charset="-120"/>
+              </a:rPr>
+              <a:t>state and grid rules from curated YAML,</a:t>
+            </a:r>
+            <a:endParaRPr lang="en-US" sz="1300" dirty="0"/>
+          </a:p>
+          <a:p>
+            <a:pPr algn="l" indent="0" marL="0">
+              <a:lnSpc>
+                <a:spcPts val="1630"/>
+              </a:lnSpc>
+              <a:buNone/>
+            </a:pPr>
+            <a:r>
+              <a:rPr lang="en-US" sz="1300" dirty="0">
+                <a:solidFill>
+                  <a:srgbClr val="15131A"/>
+                </a:solidFill>
+                <a:latin typeface="Pretendard" pitchFamily="34" charset="0"/>
+                <a:ea typeface="Pretendard" pitchFamily="34" charset="-122"/>
+                <a:cs typeface="Pretendard" pitchFamily="34" charset="-120"/>
+              </a:rPr>
+              <a:t>county sources (draft ordinance, press</a:t>
+            </a:r>
+            <a:endParaRPr lang="en-US" sz="1300" dirty="0"/>
+          </a:p>
+          <a:p>
+            <a:pPr algn="l" indent="0" marL="0">
+              <a:lnSpc>
+                <a:spcPts val="1630"/>
+              </a:lnSpc>
+              <a:buNone/>
+            </a:pPr>
+            <a:r>
+              <a:rPr lang="en-US" sz="1300" dirty="0">
+                <a:solidFill>
+                  <a:srgbClr val="15131A"/>
+                </a:solidFill>
+                <a:latin typeface="Pretendard" pitchFamily="34" charset="0"/>
+                <a:ea typeface="Pretendard" pitchFamily="34" charset="-122"/>
+                <a:cs typeface="Pretendard" pitchFamily="34" charset="-120"/>
+              </a:rPr>
+              <a:t>release, news article) with</a:t>
+            </a:r>
+            <a:endParaRPr lang="en-US" sz="1300" dirty="0"/>
+          </a:p>
+          <a:p>
+            <a:pPr algn="l" indent="0" marL="0">
+              <a:lnSpc>
+                <a:spcPts val="1630"/>
+              </a:lnSpc>
+              <a:buNone/>
+            </a:pPr>
+            <a:r>
+              <a:rPr lang="en-US" sz="1300" dirty="0">
+                <a:solidFill>
+                  <a:srgbClr val="15131A"/>
+                </a:solidFill>
+                <a:latin typeface="Pretendard" pitchFamily="34" charset="0"/>
+                <a:ea typeface="Pretendard" pitchFamily="34" charset="-122"/>
+                <a:cs typeface="Pretendard" pitchFamily="34" charset="-120"/>
+              </a:rPr>
+              <a:t>verbatim-verified quotes.</a:t>
+            </a:r>
+            <a:endParaRPr lang="en-US" sz="1300" dirty="0"/>
+          </a:p>
         </p:txBody>
       </p:sp>
       <p:sp>
@@ -8097,7 +8237,7 @@
         </p:nvSpPr>
         <p:spPr>
           <a:xfrm>
-            <a:off x="9220200" y="5132388"/>
+            <a:off x="8229600" y="4513263"/>
             <a:ext cx="50800" cy="50800"/>
           </a:xfrm>
           <a:prstGeom prst="rect">
@@ -8117,8 +8257,8 @@
         </p:nvSpPr>
         <p:spPr>
           <a:xfrm>
-            <a:off x="9398000" y="5054600"/>
-            <a:ext cx="2489200" cy="412750"/>
+            <a:off x="8407400" y="4435475"/>
+            <a:ext cx="3479800" cy="206375"/>
           </a:xfrm>
           <a:prstGeom prst="rect">
             <a:avLst/>
@@ -8145,30 +8285,10 @@
                 <a:ea typeface="Pretendard" pitchFamily="34" charset="-122"/>
                 <a:cs typeface="Pretendard" pitchFamily="34" charset="-120"/>
               </a:rPr>
-              <a:t>A screening tool, not</a:t>
+              <a:t>A screening tool, not legal advice.</a:t>
             </a:r>
             <a:endParaRPr lang="en-US" sz="1300" dirty="0"/>
           </a:p>
-          <a:p>
-            <a:pPr algn="l" indent="0" marL="0">
-              <a:lnSpc>
-                <a:spcPts val="1630"/>
-              </a:lnSpc>
-              <a:buNone/>
-            </a:pPr>
-            <a:r>
-              <a:rPr lang="en-US" sz="1300" dirty="0">
-                <a:solidFill>
-                  <a:srgbClr val="15131A"/>
-                </a:solidFill>
-                <a:latin typeface="Pretendard" pitchFamily="34" charset="0"/>
-                <a:ea typeface="Pretendard" pitchFamily="34" charset="-122"/>
-                <a:cs typeface="Pretendard" pitchFamily="34" charset="-120"/>
-              </a:rPr>
-              <a:t>legal advice.</a:t>
-            </a:r>
-            <a:endParaRPr lang="en-US" sz="1300" dirty="0"/>
-          </a:p>
         </p:txBody>
       </p:sp>
       <p:sp>
@@ -8179,8 +8299,8 @@
         </p:nvSpPr>
         <p:spPr>
           <a:xfrm>
-            <a:off x="9220200" y="6023610"/>
-            <a:ext cx="2667000" cy="148590"/>
+            <a:off x="8229600" y="6023610"/>
+            <a:ext cx="3657600" cy="148590"/>
           </a:xfrm>
           <a:prstGeom prst="rect">
             <a:avLst/>
@@ -8440,7 +8560,7 @@
         <p:spPr>
           <a:xfrm>
             <a:off x="304800" y="2614295"/>
-            <a:ext cx="1950720" cy="1651000"/>
+            <a:ext cx="1950720" cy="2682875"/>
           </a:xfrm>
           <a:prstGeom prst="rect">
             <a:avLst/>
@@ -8467,7 +8587,7 @@
                 <a:ea typeface="Pretendard" pitchFamily="34" charset="-122"/>
                 <a:cs typeface="Pretendard" pitchFamily="34" charset="-120"/>
               </a:rPr>
-              <a:t>the planner drafts targeted tasks per layer on Nemotron Ultra · Input: site, MW, jurisdiction match, prior critic objections · Output: federal, state and county investigator tasks</a:t>
+              <a:t>the planner drafts targeted county investigation tasks on Nemotron Ultra (planning) · Input: site, MW, jurisdiction match, prior critic objections · Output: per-rule questions for the county investigator; federal, state and grid rules come from curated YAML evaluated in code</a:t>
             </a:r>
             <a:endParaRPr lang="en-US" sz="1300" dirty="0"/>
           </a:p>
@@ -8586,7 +8706,7 @@
         <p:spPr>
           <a:xfrm>
             <a:off x="2712720" y="2614295"/>
-            <a:ext cx="1950720" cy="1857375"/>
+            <a:ext cx="1950720" cy="1651000"/>
           </a:xfrm>
           <a:prstGeom prst="rect">
             <a:avLst/>
@@ -8613,7 +8733,147 @@
                 <a:ea typeface="Pretendard" pitchFamily="34" charset="-122"/>
                 <a:cs typeface="Pretendard" pitchFamily="34" charset="-120"/>
               </a:rPr>
-              <a:t>layer investigators gather candidate rules with quoted text · Lightning extraction; the county loop uses Markovian chunked reasoning · Output: candidate rules with quotes and source locators</a:t>
+              <a:t>the county investigator</a:t>
+            </a:r>
+            <a:endParaRPr lang="en-US" sz="1300" dirty="0"/>
+          </a:p>
+          <a:p>
+            <a:pPr algn="l" indent="0" marL="0">
+              <a:lnSpc>
+                <a:spcPts val="1630"/>
+              </a:lnSpc>
+              <a:buNone/>
+            </a:pPr>
+            <a:r>
+              <a:rPr lang="en-US" sz="1300" dirty="0">
+                <a:solidFill>
+                  <a:srgbClr val="55525C"/>
+                </a:solidFill>
+                <a:latin typeface="Pretendard" pitchFamily="34" charset="0"/>
+                <a:ea typeface="Pretendard" pitchFamily="34" charset="-122"/>
+                <a:cs typeface="Pretendard" pitchFamily="34" charset="-120"/>
+              </a:rPr>
+              <a:t>reads primary sources ·</a:t>
+            </a:r>
+            <a:endParaRPr lang="en-US" sz="1300" dirty="0"/>
+          </a:p>
+          <a:p>
+            <a:pPr algn="l" indent="0" marL="0">
+              <a:lnSpc>
+                <a:spcPts val="1630"/>
+              </a:lnSpc>
+              <a:buNone/>
+            </a:pPr>
+            <a:r>
+              <a:rPr lang="en-US" sz="1300" dirty="0">
+                <a:solidFill>
+                  <a:srgbClr val="55525C"/>
+                </a:solidFill>
+                <a:latin typeface="Pretendard" pitchFamily="34" charset="0"/>
+                <a:ea typeface="Pretendard" pitchFamily="34" charset="-122"/>
+                <a:cs typeface="Pretendard" pitchFamily="34" charset="-120"/>
+              </a:rPr>
+              <a:t>Lightning extraction</a:t>
+            </a:r>
+            <a:endParaRPr lang="en-US" sz="1300" dirty="0"/>
+          </a:p>
+          <a:p>
+            <a:pPr algn="l" indent="0" marL="0">
+              <a:lnSpc>
+                <a:spcPts val="1630"/>
+              </a:lnSpc>
+              <a:buNone/>
+            </a:pPr>
+            <a:r>
+              <a:rPr lang="en-US" sz="1300" dirty="0">
+                <a:solidFill>
+                  <a:srgbClr val="55525C"/>
+                </a:solidFill>
+                <a:latin typeface="Pretendard" pitchFamily="34" charset="0"/>
+                <a:ea typeface="Pretendard" pitchFamily="34" charset="-122"/>
+                <a:cs typeface="Pretendard" pitchFamily="34" charset="-120"/>
+              </a:rPr>
+              <a:t>only, Markovian chunk</a:t>
+            </a:r>
+            <a:endParaRPr lang="en-US" sz="1300" dirty="0"/>
+          </a:p>
+          <a:p>
+            <a:pPr algn="l" indent="0" marL="0">
+              <a:lnSpc>
+                <a:spcPts val="1630"/>
+              </a:lnSpc>
+              <a:buNone/>
+            </a:pPr>
+            <a:r>
+              <a:rPr lang="en-US" sz="1300" dirty="0">
+                <a:solidFill>
+                  <a:srgbClr val="55525C"/>
+                </a:solidFill>
+                <a:latin typeface="Pretendard" pitchFamily="34" charset="0"/>
+                <a:ea typeface="Pretendard" pitchFamily="34" charset="-122"/>
+                <a:cs typeface="Pretendard" pitchFamily="34" charset="-120"/>
+              </a:rPr>
+              <a:t>chain; quotes verbatim ·</a:t>
+            </a:r>
+            <a:endParaRPr lang="en-US" sz="1300" dirty="0"/>
+          </a:p>
+          <a:p>
+            <a:pPr algn="l" indent="0" marL="0">
+              <a:lnSpc>
+                <a:spcPts val="1630"/>
+              </a:lnSpc>
+              <a:buNone/>
+            </a:pPr>
+            <a:r>
+              <a:rPr lang="en-US" sz="1300" dirty="0">
+                <a:solidFill>
+                  <a:srgbClr val="55525C"/>
+                </a:solidFill>
+                <a:latin typeface="Pretendard" pitchFamily="34" charset="0"/>
+                <a:ea typeface="Pretendard" pitchFamily="34" charset="-122"/>
+                <a:cs typeface="Pretendard" pitchFamily="34" charset="-120"/>
+              </a:rPr>
+              <a:t>Output: facts with</a:t>
+            </a:r>
+            <a:endParaRPr lang="en-US" sz="1300" dirty="0"/>
+          </a:p>
+          <a:p>
+            <a:pPr algn="l" indent="0" marL="0">
+              <a:lnSpc>
+                <a:spcPts val="1630"/>
+              </a:lnSpc>
+              <a:buNone/>
+            </a:pPr>
+            <a:r>
+              <a:rPr lang="en-US" sz="1300" dirty="0">
+                <a:solidFill>
+                  <a:srgbClr val="55525C"/>
+                </a:solidFill>
+                <a:latin typeface="Pretendard" pitchFamily="34" charset="0"/>
+                <a:ea typeface="Pretendard" pitchFamily="34" charset="-122"/>
+                <a:cs typeface="Pretendard" pitchFamily="34" charset="-120"/>
+              </a:rPr>
+              <a:t>verbatim quotes and</a:t>
+            </a:r>
+            <a:endParaRPr lang="en-US" sz="1300" dirty="0"/>
+          </a:p>
+          <a:p>
+            <a:pPr algn="l" indent="0" marL="0">
+              <a:lnSpc>
+                <a:spcPts val="1630"/>
+              </a:lnSpc>
+              <a:buNone/>
+            </a:pPr>
+            <a:r>
+              <a:rPr lang="en-US" sz="1300" dirty="0">
+                <a:solidFill>
+                  <a:srgbClr val="55525C"/>
+                </a:solidFill>
+                <a:latin typeface="Pretendard" pitchFamily="34" charset="0"/>
+                <a:ea typeface="Pretendard" pitchFamily="34" charset="-122"/>
+                <a:cs typeface="Pretendard" pitchFamily="34" charset="-120"/>
+              </a:rPr>
+              <a:t>source locators</a:t>
             </a:r>
             <a:endParaRPr lang="en-US" sz="1300" dirty="0"/>
           </a:p>
@@ -8759,7 +9019,7 @@
                 <a:ea typeface="Pretendard" pitchFamily="34" charset="-122"/>
                 <a:cs typeface="Pretendard" pitchFamily="34" charset="-120"/>
               </a:rPr>
-              <a:t>deterministic quote check plus Lightning verify_support, retry at most twice · Unverifiable claims become needs_confirmation, never fatal verdicts · Output: verified, not_found or unsupported per claim</a:t>
+              <a:t>deterministic verbatim quote matching in code, retry at most twice · Unverifiable claims become needs_confirmation, never fatal verdicts · Output: verified, not_found or unsupported per claim</a:t>
             </a:r>
             <a:endParaRPr lang="en-US" sz="1300" dirty="0"/>
           </a:p>
@@ -8878,7 +9138,7 @@
         <p:spPr>
           <a:xfrm>
             <a:off x="7528560" y="2614295"/>
-            <a:ext cx="1950720" cy="1651000"/>
+            <a:ext cx="1950720" cy="1857375"/>
           </a:xfrm>
           <a:prstGeom prst="rect">
             <a:avLst/>
@@ -8905,7 +9165,167 @@
                 <a:ea typeface="Pretendard" pitchFamily="34" charset="-122"/>
                 <a:cs typeface="Pretendard" pitchFamily="34" charset="-120"/>
               </a:rPr>
-              <a:t>Python applicability decides yes or no; the adjudicator drafts the verdict · The adjudicator runs on Nemotron Ultra · Output: draft verdict with the why-chain and the flips table</a:t>
+              <a:t>Python applicability</a:t>
+            </a:r>
+            <a:endParaRPr lang="en-US" sz="1300" dirty="0"/>
+          </a:p>
+          <a:p>
+            <a:pPr algn="l" indent="0" marL="0">
+              <a:lnSpc>
+                <a:spcPts val="1630"/>
+              </a:lnSpc>
+              <a:buNone/>
+            </a:pPr>
+            <a:r>
+              <a:rPr lang="en-US" sz="1300" dirty="0">
+                <a:solidFill>
+                  <a:srgbClr val="55525C"/>
+                </a:solidFill>
+                <a:latin typeface="Pretendard" pitchFamily="34" charset="0"/>
+                <a:ea typeface="Pretendard" pitchFamily="34" charset="-122"/>
+                <a:cs typeface="Pretendard" pitchFamily="34" charset="-120"/>
+              </a:rPr>
+              <a:t>decides yes or no; the</a:t>
+            </a:r>
+            <a:endParaRPr lang="en-US" sz="1300" dirty="0"/>
+          </a:p>
+          <a:p>
+            <a:pPr algn="l" indent="0" marL="0">
+              <a:lnSpc>
+                <a:spcPts val="1630"/>
+              </a:lnSpc>
+              <a:buNone/>
+            </a:pPr>
+            <a:r>
+              <a:rPr lang="en-US" sz="1300" dirty="0">
+                <a:solidFill>
+                  <a:srgbClr val="55525C"/>
+                </a:solidFill>
+                <a:latin typeface="Pretendard" pitchFamily="34" charset="0"/>
+                <a:ea typeface="Pretendard" pitchFamily="34" charset="-122"/>
+                <a:cs typeface="Pretendard" pitchFamily="34" charset="-120"/>
+              </a:rPr>
+              <a:t>adjudicator drafts the</a:t>
+            </a:r>
+            <a:endParaRPr lang="en-US" sz="1300" dirty="0"/>
+          </a:p>
+          <a:p>
+            <a:pPr algn="l" indent="0" marL="0">
+              <a:lnSpc>
+                <a:spcPts val="1630"/>
+              </a:lnSpc>
+              <a:buNone/>
+            </a:pPr>
+            <a:r>
+              <a:rPr lang="en-US" sz="1300" dirty="0">
+                <a:solidFill>
+                  <a:srgbClr val="55525C"/>
+                </a:solidFill>
+                <a:latin typeface="Pretendard" pitchFamily="34" charset="0"/>
+                <a:ea typeface="Pretendard" pitchFamily="34" charset="-122"/>
+                <a:cs typeface="Pretendard" pitchFamily="34" charset="-120"/>
+              </a:rPr>
+              <a:t>verdict · The</a:t>
+            </a:r>
+            <a:endParaRPr lang="en-US" sz="1300" dirty="0"/>
+          </a:p>
+          <a:p>
+            <a:pPr algn="l" indent="0" marL="0">
+              <a:lnSpc>
+                <a:spcPts val="1630"/>
+              </a:lnSpc>
+              <a:buNone/>
+            </a:pPr>
+            <a:r>
+              <a:rPr lang="en-US" sz="1300" dirty="0">
+                <a:solidFill>
+                  <a:srgbClr val="55525C"/>
+                </a:solidFill>
+                <a:latin typeface="Pretendard" pitchFamily="34" charset="0"/>
+                <a:ea typeface="Pretendard" pitchFamily="34" charset="-122"/>
+                <a:cs typeface="Pretendard" pitchFamily="34" charset="-120"/>
+              </a:rPr>
+              <a:t>adjudicator synthesizes</a:t>
+            </a:r>
+            <a:endParaRPr lang="en-US" sz="1300" dirty="0"/>
+          </a:p>
+          <a:p>
+            <a:pPr algn="l" indent="0" marL="0">
+              <a:lnSpc>
+                <a:spcPts val="1630"/>
+              </a:lnSpc>
+              <a:buNone/>
+            </a:pPr>
+            <a:r>
+              <a:rPr lang="en-US" sz="1300" dirty="0">
+                <a:solidFill>
+                  <a:srgbClr val="55525C"/>
+                </a:solidFill>
+                <a:latin typeface="Pretendard" pitchFamily="34" charset="0"/>
+                <a:ea typeface="Pretendard" pitchFamily="34" charset="-122"/>
+                <a:cs typeface="Pretendard" pitchFamily="34" charset="-120"/>
+              </a:rPr>
+              <a:t>on Nemotron Ultra ·</a:t>
+            </a:r>
+            <a:endParaRPr lang="en-US" sz="1300" dirty="0"/>
+          </a:p>
+          <a:p>
+            <a:pPr algn="l" indent="0" marL="0">
+              <a:lnSpc>
+                <a:spcPts val="1630"/>
+              </a:lnSpc>
+              <a:buNone/>
+            </a:pPr>
+            <a:r>
+              <a:rPr lang="en-US" sz="1300" dirty="0">
+                <a:solidFill>
+                  <a:srgbClr val="55525C"/>
+                </a:solidFill>
+                <a:latin typeface="Pretendard" pitchFamily="34" charset="0"/>
+                <a:ea typeface="Pretendard" pitchFamily="34" charset="-122"/>
+                <a:cs typeface="Pretendard" pitchFamily="34" charset="-120"/>
+              </a:rPr>
+              <a:t>Output: draft verdict</a:t>
+            </a:r>
+            <a:endParaRPr lang="en-US" sz="1300" dirty="0"/>
+          </a:p>
+          <a:p>
+            <a:pPr algn="l" indent="0" marL="0">
+              <a:lnSpc>
+                <a:spcPts val="1630"/>
+              </a:lnSpc>
+              <a:buNone/>
+            </a:pPr>
+            <a:r>
+              <a:rPr lang="en-US" sz="1300" dirty="0">
+                <a:solidFill>
+                  <a:srgbClr val="55525C"/>
+                </a:solidFill>
+                <a:latin typeface="Pretendard" pitchFamily="34" charset="0"/>
+                <a:ea typeface="Pretendard" pitchFamily="34" charset="-122"/>
+                <a:cs typeface="Pretendard" pitchFamily="34" charset="-120"/>
+              </a:rPr>
+              <a:t>with the why-chain and</a:t>
+            </a:r>
+            <a:endParaRPr lang="en-US" sz="1300" dirty="0"/>
+          </a:p>
+          <a:p>
+            <a:pPr algn="l" indent="0" marL="0">
+              <a:lnSpc>
+                <a:spcPts val="1630"/>
+              </a:lnSpc>
+              <a:buNone/>
+            </a:pPr>
+            <a:r>
+              <a:rPr lang="en-US" sz="1300" dirty="0">
+                <a:solidFill>
+                  <a:srgbClr val="55525C"/>
+                </a:solidFill>
+                <a:latin typeface="Pretendard" pitchFamily="34" charset="0"/>
+                <a:ea typeface="Pretendard" pitchFamily="34" charset="-122"/>
+                <a:cs typeface="Pretendard" pitchFamily="34" charset="-120"/>
+              </a:rPr>
+              <a:t>the flips table</a:t>
             </a:r>
             <a:endParaRPr lang="en-US" sz="1300" dirty="0"/>
           </a:p>
@@ -9024,7 +9444,7 @@
         <p:spPr>
           <a:xfrm>
             <a:off x="9936480" y="2614295"/>
-            <a:ext cx="1950720" cy="2476500"/>
+            <a:ext cx="1950720" cy="2682875"/>
           </a:xfrm>
           <a:prstGeom prst="rect">
             <a:avLst/>
@@ -9051,7 +9471,247 @@
                 <a:ea typeface="Pretendard" pitchFamily="34" charset="-122"/>
                 <a:cs typeface="Pretendard" pitchFamily="34" charset="-120"/>
               </a:rPr>
-              <a:t>red-team objections loop back to the planner for round 2 · New investigator and verifier passes target the objections; every message is a typed event in the World Model log · Unresolved objections become needs_confirmation; UI lanes show the model and receipt per request</a:t>
+              <a:t>red-team objections</a:t>
+            </a:r>
+            <a:endParaRPr lang="en-US" sz="1300" dirty="0"/>
+          </a:p>
+          <a:p>
+            <a:pPr algn="l" indent="0" marL="0">
+              <a:lnSpc>
+                <a:spcPts val="1630"/>
+              </a:lnSpc>
+              <a:buNone/>
+            </a:pPr>
+            <a:r>
+              <a:rPr lang="en-US" sz="1300" dirty="0">
+                <a:solidFill>
+                  <a:srgbClr val="55525C"/>
+                </a:solidFill>
+                <a:latin typeface="Pretendard" pitchFamily="34" charset="0"/>
+                <a:ea typeface="Pretendard" pitchFamily="34" charset="-122"/>
+                <a:cs typeface="Pretendard" pitchFamily="34" charset="-120"/>
+              </a:rPr>
+              <a:t>(critique) loop back to</a:t>
+            </a:r>
+            <a:endParaRPr lang="en-US" sz="1300" dirty="0"/>
+          </a:p>
+          <a:p>
+            <a:pPr algn="l" indent="0" marL="0">
+              <a:lnSpc>
+                <a:spcPts val="1630"/>
+              </a:lnSpc>
+              <a:buNone/>
+            </a:pPr>
+            <a:r>
+              <a:rPr lang="en-US" sz="1300" dirty="0">
+                <a:solidFill>
+                  <a:srgbClr val="55525C"/>
+                </a:solidFill>
+                <a:latin typeface="Pretendard" pitchFamily="34" charset="0"/>
+                <a:ea typeface="Pretendard" pitchFamily="34" charset="-122"/>
+                <a:cs typeface="Pretendard" pitchFamily="34" charset="-120"/>
+              </a:rPr>
+              <a:t>the planner for round</a:t>
+            </a:r>
+            <a:endParaRPr lang="en-US" sz="1300" dirty="0"/>
+          </a:p>
+          <a:p>
+            <a:pPr algn="l" indent="0" marL="0">
+              <a:lnSpc>
+                <a:spcPts val="1630"/>
+              </a:lnSpc>
+              <a:buNone/>
+            </a:pPr>
+            <a:r>
+              <a:rPr lang="en-US" sz="1300" dirty="0">
+                <a:solidFill>
+                  <a:srgbClr val="55525C"/>
+                </a:solidFill>
+                <a:latin typeface="Pretendard" pitchFamily="34" charset="0"/>
+                <a:ea typeface="Pretendard" pitchFamily="34" charset="-122"/>
+                <a:cs typeface="Pretendard" pitchFamily="34" charset="-120"/>
+              </a:rPr>
+              <a:t>2 · New investigator and</a:t>
+            </a:r>
+            <a:endParaRPr lang="en-US" sz="1300" dirty="0"/>
+          </a:p>
+          <a:p>
+            <a:pPr algn="l" indent="0" marL="0">
+              <a:lnSpc>
+                <a:spcPts val="1630"/>
+              </a:lnSpc>
+              <a:buNone/>
+            </a:pPr>
+            <a:r>
+              <a:rPr lang="en-US" sz="1300" dirty="0">
+                <a:solidFill>
+                  <a:srgbClr val="55525C"/>
+                </a:solidFill>
+                <a:latin typeface="Pretendard" pitchFamily="34" charset="0"/>
+                <a:ea typeface="Pretendard" pitchFamily="34" charset="-122"/>
+                <a:cs typeface="Pretendard" pitchFamily="34" charset="-120"/>
+              </a:rPr>
+              <a:t>verifier passes target</a:t>
+            </a:r>
+            <a:endParaRPr lang="en-US" sz="1300" dirty="0"/>
+          </a:p>
+          <a:p>
+            <a:pPr algn="l" indent="0" marL="0">
+              <a:lnSpc>
+                <a:spcPts val="1630"/>
+              </a:lnSpc>
+              <a:buNone/>
+            </a:pPr>
+            <a:r>
+              <a:rPr lang="en-US" sz="1300" dirty="0">
+                <a:solidFill>
+                  <a:srgbClr val="55525C"/>
+                </a:solidFill>
+                <a:latin typeface="Pretendard" pitchFamily="34" charset="0"/>
+                <a:ea typeface="Pretendard" pitchFamily="34" charset="-122"/>
+                <a:cs typeface="Pretendard" pitchFamily="34" charset="-120"/>
+              </a:rPr>
+              <a:t>the objections; every</a:t>
+            </a:r>
+            <a:endParaRPr lang="en-US" sz="1300" dirty="0"/>
+          </a:p>
+          <a:p>
+            <a:pPr algn="l" indent="0" marL="0">
+              <a:lnSpc>
+                <a:spcPts val="1630"/>
+              </a:lnSpc>
+              <a:buNone/>
+            </a:pPr>
+            <a:r>
+              <a:rPr lang="en-US" sz="1300" dirty="0">
+                <a:solidFill>
+                  <a:srgbClr val="55525C"/>
+                </a:solidFill>
+                <a:latin typeface="Pretendard" pitchFamily="34" charset="0"/>
+                <a:ea typeface="Pretendard" pitchFamily="34" charset="-122"/>
+                <a:cs typeface="Pretendard" pitchFamily="34" charset="-120"/>
+              </a:rPr>
+              <a:t>message is a typed event</a:t>
+            </a:r>
+            <a:endParaRPr lang="en-US" sz="1300" dirty="0"/>
+          </a:p>
+          <a:p>
+            <a:pPr algn="l" indent="0" marL="0">
+              <a:lnSpc>
+                <a:spcPts val="1630"/>
+              </a:lnSpc>
+              <a:buNone/>
+            </a:pPr>
+            <a:r>
+              <a:rPr lang="en-US" sz="1300" dirty="0">
+                <a:solidFill>
+                  <a:srgbClr val="55525C"/>
+                </a:solidFill>
+                <a:latin typeface="Pretendard" pitchFamily="34" charset="0"/>
+                <a:ea typeface="Pretendard" pitchFamily="34" charset="-122"/>
+                <a:cs typeface="Pretendard" pitchFamily="34" charset="-120"/>
+              </a:rPr>
+              <a:t>in the World Model log ·</a:t>
+            </a:r>
+            <a:endParaRPr lang="en-US" sz="1300" dirty="0"/>
+          </a:p>
+          <a:p>
+            <a:pPr algn="l" indent="0" marL="0">
+              <a:lnSpc>
+                <a:spcPts val="1630"/>
+              </a:lnSpc>
+              <a:buNone/>
+            </a:pPr>
+            <a:r>
+              <a:rPr lang="en-US" sz="1300" dirty="0">
+                <a:solidFill>
+                  <a:srgbClr val="55525C"/>
+                </a:solidFill>
+                <a:latin typeface="Pretendard" pitchFamily="34" charset="0"/>
+                <a:ea typeface="Pretendard" pitchFamily="34" charset="-122"/>
+                <a:cs typeface="Pretendard" pitchFamily="34" charset="-120"/>
+              </a:rPr>
+              <a:t>Unresolved objections</a:t>
+            </a:r>
+            <a:endParaRPr lang="en-US" sz="1300" dirty="0"/>
+          </a:p>
+          <a:p>
+            <a:pPr algn="l" indent="0" marL="0">
+              <a:lnSpc>
+                <a:spcPts val="1630"/>
+              </a:lnSpc>
+              <a:buNone/>
+            </a:pPr>
+            <a:r>
+              <a:rPr lang="en-US" sz="1300" dirty="0">
+                <a:solidFill>
+                  <a:srgbClr val="55525C"/>
+                </a:solidFill>
+                <a:latin typeface="Pretendard" pitchFamily="34" charset="0"/>
+                <a:ea typeface="Pretendard" pitchFamily="34" charset="-122"/>
+                <a:cs typeface="Pretendard" pitchFamily="34" charset="-120"/>
+              </a:rPr>
+              <a:t>become</a:t>
+            </a:r>
+            <a:endParaRPr lang="en-US" sz="1300" dirty="0"/>
+          </a:p>
+          <a:p>
+            <a:pPr algn="l" indent="0" marL="0">
+              <a:lnSpc>
+                <a:spcPts val="1630"/>
+              </a:lnSpc>
+              <a:buNone/>
+            </a:pPr>
+            <a:r>
+              <a:rPr lang="en-US" sz="1300" dirty="0">
+                <a:solidFill>
+                  <a:srgbClr val="55525C"/>
+                </a:solidFill>
+                <a:latin typeface="Pretendard" pitchFamily="34" charset="0"/>
+                <a:ea typeface="Pretendard" pitchFamily="34" charset="-122"/>
+                <a:cs typeface="Pretendard" pitchFamily="34" charset="-120"/>
+              </a:rPr>
+              <a:t>needs_confirmation; UI</a:t>
+            </a:r>
+            <a:endParaRPr lang="en-US" sz="1300" dirty="0"/>
+          </a:p>
+          <a:p>
+            <a:pPr algn="l" indent="0" marL="0">
+              <a:lnSpc>
+                <a:spcPts val="1630"/>
+              </a:lnSpc>
+              <a:buNone/>
+            </a:pPr>
+            <a:r>
+              <a:rPr lang="en-US" sz="1300" dirty="0">
+                <a:solidFill>
+                  <a:srgbClr val="55525C"/>
+                </a:solidFill>
+                <a:latin typeface="Pretendard" pitchFamily="34" charset="0"/>
+                <a:ea typeface="Pretendard" pitchFamily="34" charset="-122"/>
+                <a:cs typeface="Pretendard" pitchFamily="34" charset="-120"/>
+              </a:rPr>
+              <a:t>lanes show the model and</a:t>
+            </a:r>
+            <a:endParaRPr lang="en-US" sz="1300" dirty="0"/>
+          </a:p>
+          <a:p>
+            <a:pPr algn="l" indent="0" marL="0">
+              <a:lnSpc>
+                <a:spcPts val="1630"/>
+              </a:lnSpc>
+              <a:buNone/>
+            </a:pPr>
+            <a:r>
+              <a:rPr lang="en-US" sz="1300" dirty="0">
+                <a:solidFill>
+                  <a:srgbClr val="55525C"/>
+                </a:solidFill>
+                <a:latin typeface="Pretendard" pitchFamily="34" charset="0"/>
+                <a:ea typeface="Pretendard" pitchFamily="34" charset="-122"/>
+                <a:cs typeface="Pretendard" pitchFamily="34" charset="-120"/>
+              </a:rPr>
+              <a:t>receipt per request</a:t>
             </a:r>
             <a:endParaRPr lang="en-US" sz="1300" dirty="0"/>
           </a:p>
@@ -9761,7 +10421,7 @@
                           <a:ea typeface="Pretendard" pitchFamily="34" charset="-122"/>
                           <a:cs typeface="Pretendard" pitchFamily="34" charset="-120"/>
                         </a:rPr>
-                        <a:t>Nemotron Lightning 30B for extraction and verification; Nemotron Ultra 550B for planning and critique</a:t>
+                        <a:t>Nemotron Lightning 30B for county extraction; Nemotron Ultra 550B for planning, synthesis and critique</a:t>
                       </a:r>
                       <a:endParaRPr lang="en-US" sz="1100" dirty="0">
                         <a:latin typeface="Pretendard" charset="0"/>
@@ -9984,7 +10644,7 @@
                 <a:ea typeface="Pretendard" pitchFamily="34" charset="-122"/>
                 <a:cs typeface="Pretendard" pitchFamily="34" charset="-120"/>
               </a:rPr>
-              <a:t>One run at a time; a run past its 5-minute deadline returns a partial needs_confirmation report</a:t>
+              <a:t>One run at a time; a run past its deadline returns a partial needs_confirmation report instead</a:t>
             </a:r>
             <a:endParaRPr lang="en-US" sz="1300" dirty="0"/>
           </a:p>
@@ -10004,7 +10664,7 @@
                 <a:ea typeface="Pretendard" pitchFamily="34" charset="-122"/>
                 <a:cs typeface="Pretendard" pitchFamily="34" charset="-120"/>
               </a:rPr>
-              <a:t>instead of hanging.</a:t>
+              <a:t>of hanging.</a:t>
             </a:r>
             <a:endParaRPr lang="en-US" sz="1300" dirty="0"/>
           </a:p>
@@ -10306,16 +10966,16 @@
         </p:nvGraphicFramePr>
         <p:xfrm>
           <a:off x="304800" y="1524000"/>
-          <a:ext cx="11582400" cy="1699260"/>
+          <a:ext cx="7620000" cy="1470025"/>
         </p:xfrm>
         <a:graphic>
           <a:graphicData uri="http://schemas.openxmlformats.org/drawingml/2006/table">
             <a:tbl>
               <a:tblPr/>
               <a:tblGrid>
-                <a:gridCol w="2415961"/>
-                <a:gridCol w="4760864"/>
-                <a:gridCol w="4405575"/>
+                <a:gridCol w="1809065"/>
+                <a:gridCol w="2412086"/>
+                <a:gridCol w="3398849"/>
               </a:tblGrid>
               <a:tr h="354965">
                 <a:tc>
@@ -10335,7 +10995,7 @@
                           <a:ea typeface="Pretendard" pitchFamily="34" charset="-122"/>
                           <a:cs typeface="Pretendard" pitchFamily="34" charset="-120"/>
                         </a:rPr>
-                        <a:t>USL rows</a:t>
+                        <a:t>Runtime tables</a:t>
                       </a:r>
                       <a:endParaRPr lang="en-US" sz="1100" dirty="0">
                         <a:latin typeface="Pretendard" charset="0"/>
@@ -10388,7 +11048,7 @@
                           <a:ea typeface="Pretendard" pitchFamily="34" charset="-122"/>
                           <a:cs typeface="Pretendard" pitchFamily="34" charset="-120"/>
                         </a:rPr>
-                        <a:t>Source tables</a:t>
+                        <a:t>USL artifact rows</a:t>
                       </a:r>
                       <a:endParaRPr lang="en-US" sz="1100" dirty="0">
                         <a:latin typeface="Pretendard" charset="0"/>
@@ -10478,7 +11138,7 @@
                   </a:tcPr>
                 </a:tc>
               </a:tr>
-              <a:tr h="570865">
+              <a:tr h="557530">
                 <a:tc>
                   <a:txBody>
                     <a:bodyPr/>
@@ -10496,7 +11156,28 @@
                           <a:ea typeface="Pretendard" pitchFamily="34" charset="-122"/>
                           <a:cs typeface="Pretendard" pitchFamily="34" charset="-120"/>
                         </a:rPr>
-                        <a:t>1,291</a:t>
+                        <a:t>moratoria plus</a:t>
+                      </a:r>
+                      <a:endParaRPr lang="en-US" sz="1100" dirty="0">
+                        <a:latin typeface="Pretendard" charset="0"/>
+                        <a:ea typeface="Pretendard" charset="0"/>
+                        <a:cs typeface="Pretendard" charset="0"/>
+                      </a:endParaRPr>
+                    </a:p>
+                    <a:p>
+                      <a:pPr algn="l" indent="0" marL="0">
+                        <a:buNone/>
+                      </a:pPr>
+                      <a:r>
+                        <a:rPr lang="en-US" sz="1100" dirty="0">
+                          <a:solidFill>
+                            <a:srgbClr val="15131A"/>
+                          </a:solidFill>
+                          <a:latin typeface="Pretendard" pitchFamily="34" charset="0"/>
+                          <a:ea typeface="Pretendard" pitchFamily="34" charset="-122"/>
+                          <a:cs typeface="Pretendard" pitchFamily="34" charset="-120"/>
+                        </a:rPr>
+                        <a:t>state_legislation</a:t>
                       </a:r>
                       <a:endParaRPr lang="en-US" sz="1100" dirty="0">
                         <a:latin typeface="Pretendard" charset="0"/>
@@ -10537,7 +11218,7 @@
                           <a:ea typeface="Pretendard" pitchFamily="34" charset="-122"/>
                           <a:cs typeface="Pretendard" pitchFamily="34" charset="-120"/>
                         </a:rPr>
-                        <a:t>4</a:t>
+                        <a:t>1,291</a:t>
                       </a:r>
                       <a:endParaRPr lang="en-US" sz="1100" dirty="0">
                         <a:latin typeface="Pretendard" charset="0"/>
@@ -10603,7 +11284,7 @@
                   </a:tcPr>
                 </a:tc>
               </a:tr>
-              <a:tr h="773430">
+              <a:tr h="557530">
                 <a:tc>
                   <a:txBody>
                     <a:bodyPr/>
@@ -10621,7 +11302,7 @@
                           <a:ea typeface="Pretendard" pitchFamily="34" charset="-122"/>
                           <a:cs typeface="Pretendard" pitchFamily="34" charset="-120"/>
                         </a:rPr>
-                        <a:t>usl_site_screen,</a:t>
+                        <a:t>queried by the agents</a:t>
                       </a:r>
                       <a:endParaRPr lang="en-US" sz="1100" dirty="0">
                         <a:latin typeface="Pretendard" charset="0"/>
@@ -10642,7 +11323,7 @@
                           <a:ea typeface="Pretendard" pitchFamily="34" charset="-122"/>
                           <a:cs typeface="Pretendard" pitchFamily="34" charset="-120"/>
                         </a:rPr>
-                        <a:t>materialized join</a:t>
+                        <a:t>at run time</a:t>
                       </a:r>
                       <a:endParaRPr lang="en-US" sz="1100" dirty="0">
                         <a:latin typeface="Pretendard" charset="0"/>
@@ -10689,7 +11370,7 @@
                           <a:ea typeface="Pretendard" pitchFamily="34" charset="-122"/>
                           <a:cs typeface="Pretendard" pitchFamily="34" charset="-120"/>
                         </a:rPr>
-                        <a:t>moratoria 1,291; legislation 440; curated rules 3; county</a:t>
+                        <a:t>usl_site_screen from 4 seed</a:t>
                       </a:r>
                       <a:endParaRPr lang="en-US" sz="1100" dirty="0">
                         <a:latin typeface="Pretendard" charset="0"/>
@@ -10710,7 +11391,7 @@
                           <a:ea typeface="Pretendard" pitchFamily="34" charset="-122"/>
                           <a:cs typeface="Pretendard" pitchFamily="34" charset="-120"/>
                         </a:rPr>
-                        <a:t>sources 3</a:t>
+                        <a:t>tables, scripted</a:t>
                       </a:r>
                       <a:endParaRPr lang="en-US" sz="1100" dirty="0">
                         <a:latin typeface="Pretendard" charset="0"/>
@@ -10757,7 +11438,7 @@
                           <a:ea typeface="Pretendard" pitchFamily="34" charset="-122"/>
                           <a:cs typeface="Pretendard" pitchFamily="34" charset="-120"/>
                         </a:rPr>
-                        <a:t>12 exploratory plus 3 USL queries; null_join_keys</a:t>
+                        <a:t>12 exploratory plus 3 USL queries;</a:t>
                       </a:r>
                       <a:endParaRPr lang="en-US" sz="1100" dirty="0">
                         <a:latin typeface="Pretendard" charset="0"/>
@@ -10778,7 +11459,7 @@
                           <a:ea typeface="Pretendard" pitchFamily="34" charset="-122"/>
                           <a:cs typeface="Pretendard" pitchFamily="34" charset="-120"/>
                         </a:rPr>
-                        <a:t>0 violations</a:t>
+                        <a:t>null_join_keys 0 violations</a:t>
                       </a:r>
                       <a:endParaRPr lang="en-US" sz="1100" dirty="0">
                         <a:latin typeface="Pretendard" charset="0"/>
@@ -10821,8 +11502,8 @@
         </p:nvSpPr>
         <p:spPr>
           <a:xfrm>
-            <a:off x="304800" y="3299460"/>
-            <a:ext cx="11582400" cy="181610"/>
+            <a:off x="304800" y="3070225"/>
+            <a:ext cx="7620000" cy="181610"/>
           </a:xfrm>
           <a:prstGeom prst="rect">
             <a:avLst/>
@@ -10849,7 +11530,7 @@
                 <a:ea typeface="Pretendard" pitchFamily="34" charset="-122"/>
                 <a:cs typeface="Pretendard" pitchFamily="34" charset="-120"/>
               </a:rPr>
-              <a:t>Table 3. zetaris/usl.sql and zetaris/evidence/, committed f0f2b9b</a:t>
+              <a:t>Table 3. app/screen.py, app/orchestrator.py; zetaris/usl.sql and zetaris/evidence/, committed f0f2b9b</a:t>
             </a:r>
             <a:endParaRPr lang="en-US" sz="1100" dirty="0"/>
           </a:p>
@@ -10863,7 +11544,7 @@
         </p:nvSpPr>
         <p:spPr>
           <a:xfrm>
-            <a:off x="304800" y="3787458"/>
+            <a:off x="8229600" y="1601788"/>
             <a:ext cx="50800" cy="50800"/>
           </a:xfrm>
           <a:prstGeom prst="rect">
@@ -10883,8 +11564,8 @@
         </p:nvSpPr>
         <p:spPr>
           <a:xfrm>
-            <a:off x="482600" y="3709670"/>
-            <a:ext cx="5461000" cy="1031875"/>
+            <a:off x="8407400" y="1524000"/>
+            <a:ext cx="3479800" cy="1031875"/>
           </a:xfrm>
           <a:prstGeom prst="rect">
             <a:avLst/>
@@ -10911,7 +11592,7 @@
                 <a:ea typeface="Pretendard" pitchFamily="34" charset="-122"/>
                 <a:cs typeface="Pretendard" pitchFamily="34" charset="-120"/>
               </a:rPr>
-              <a:t>Zetaris is the data layer: 4 seed tables registered from</a:t>
+              <a:t>Zetaris is the data layer: the agents</a:t>
             </a:r>
             <a:endParaRPr lang="en-US" sz="1300" dirty="0"/>
           </a:p>
@@ -10931,7 +11612,7 @@
                 <a:ea typeface="Pretendard" pitchFamily="34" charset="-122"/>
                 <a:cs typeface="Pretendard" pitchFamily="34" charset="-120"/>
               </a:rPr>
-              <a:t>data/seed CSVs join jurisdiction to moratoria, bills and</a:t>
+              <a:t>query SITEWHY.moratoria and</a:t>
             </a:r>
             <a:endParaRPr lang="en-US" sz="1300" dirty="0"/>
           </a:p>
@@ -10951,7 +11632,7 @@
                 <a:ea typeface="Pretendard" pitchFamily="34" charset="-122"/>
                 <a:cs typeface="Pretendard" pitchFamily="34" charset="-120"/>
               </a:rPr>
-              <a:t>curated rules in usl_site_screen, materialized because plain</a:t>
+              <a:t>SITEWHY.state_legislation at run time;</a:t>
             </a:r>
             <a:endParaRPr lang="en-US" sz="1300" dirty="0"/>
           </a:p>
@@ -10971,7 +11652,7 @@
                 <a:ea typeface="Pretendard" pitchFamily="34" charset="-122"/>
                 <a:cs typeface="Pretendard" pitchFamily="34" charset="-120"/>
               </a:rPr>
-              <a:t>views do not persist on this instance; DuckDB serves the same</a:t>
+              <a:t>DuckDB serves the same SQL when Zetaris</a:t>
             </a:r>
             <a:endParaRPr lang="en-US" sz="1300" dirty="0"/>
           </a:p>
@@ -10991,7 +11672,7 @@
                 <a:ea typeface="Pretendard" pitchFamily="34" charset="-122"/>
                 <a:cs typeface="Pretendard" pitchFamily="34" charset="-120"/>
               </a:rPr>
-              <a:t>SQL when unreachable.</a:t>
+              <a:t>is unreachable.</a:t>
             </a:r>
             <a:endParaRPr lang="en-US" sz="1300" dirty="0"/>
           </a:p>
@@ -11005,7 +11686,7 @@
         </p:nvSpPr>
         <p:spPr>
           <a:xfrm>
-            <a:off x="304800" y="4895533"/>
+            <a:off x="8229600" y="2709863"/>
             <a:ext cx="50800" cy="50800"/>
           </a:xfrm>
           <a:prstGeom prst="rect">
@@ -11025,8 +11706,8 @@
         </p:nvSpPr>
         <p:spPr>
           <a:xfrm>
-            <a:off x="482600" y="4817745"/>
-            <a:ext cx="5461000" cy="412750"/>
+            <a:off x="8407400" y="2632075"/>
+            <a:ext cx="3479800" cy="825500"/>
           </a:xfrm>
           <a:prstGeom prst="rect">
             <a:avLst/>
@@ -11053,7 +11734,7 @@
                 <a:ea typeface="Pretendard" pitchFamily="34" charset="-122"/>
                 <a:cs typeface="Pretendard" pitchFamily="34" charset="-120"/>
               </a:rPr>
-              <a:t>Meterless Nightshift is the primary AI provider; model and</a:t>
+              <a:t>The USL is a separate scripted artifact,</a:t>
             </a:r>
             <a:endParaRPr lang="en-US" sz="1300" dirty="0"/>
           </a:p>
@@ -11073,10 +11754,50 @@
                 <a:ea typeface="Pretendard" pitchFamily="34" charset="-122"/>
                 <a:cs typeface="Pretendard" pitchFamily="34" charset="-120"/>
               </a:rPr>
-              <a:t>compute receipt per request appear in the UI agent lanes.</a:t>
+              <a:t>materialized because plain views do not</a:t>
             </a:r>
             <a:endParaRPr lang="en-US" sz="1300" dirty="0"/>
           </a:p>
+          <a:p>
+            <a:pPr algn="l" indent="0" marL="0">
+              <a:lnSpc>
+                <a:spcPts val="1630"/>
+              </a:lnSpc>
+              <a:buNone/>
+            </a:pPr>
+            <a:r>
+              <a:rPr lang="en-US" sz="1300" dirty="0">
+                <a:solidFill>
+                  <a:srgbClr val="15131A"/>
+                </a:solidFill>
+                <a:latin typeface="Pretendard" pitchFamily="34" charset="0"/>
+                <a:ea typeface="Pretendard" pitchFamily="34" charset="-122"/>
+                <a:cs typeface="Pretendard" pitchFamily="34" charset="-120"/>
+              </a:rPr>
+              <a:t>persist on this instance — evidence the</a:t>
+            </a:r>
+            <a:endParaRPr lang="en-US" sz="1300" dirty="0"/>
+          </a:p>
+          <a:p>
+            <a:pPr algn="l" indent="0" marL="0">
+              <a:lnSpc>
+                <a:spcPts val="1630"/>
+              </a:lnSpc>
+              <a:buNone/>
+            </a:pPr>
+            <a:r>
+              <a:rPr lang="en-US" sz="1300" dirty="0">
+                <a:solidFill>
+                  <a:srgbClr val="15131A"/>
+                </a:solidFill>
+                <a:latin typeface="Pretendard" pitchFamily="34" charset="0"/>
+                <a:ea typeface="Pretendard" pitchFamily="34" charset="-122"/>
+                <a:cs typeface="Pretendard" pitchFamily="34" charset="-120"/>
+              </a:rPr>
+              <a:t>same joins hold, not yet on the agent path.</a:t>
+            </a:r>
+            <a:endParaRPr lang="en-US" sz="1300" dirty="0"/>
+          </a:p>
         </p:txBody>
       </p:sp>
       <p:sp>
@@ -11087,7 +11808,7 @@
         </p:nvSpPr>
         <p:spPr>
           <a:xfrm>
-            <a:off x="6248400" y="3787458"/>
+            <a:off x="8229600" y="3611563"/>
             <a:ext cx="50800" cy="50800"/>
           </a:xfrm>
           <a:prstGeom prst="rect">
@@ -11107,8 +11828,8 @@
         </p:nvSpPr>
         <p:spPr>
           <a:xfrm>
-            <a:off x="6426200" y="3709670"/>
-            <a:ext cx="5461000" cy="619125"/>
+            <a:off x="8407400" y="3533775"/>
+            <a:ext cx="3479800" cy="619125"/>
           </a:xfrm>
           <a:prstGeom prst="rect">
             <a:avLst/>
@@ -11135,7 +11856,7 @@
                 <a:ea typeface="Pretendard" pitchFamily="34" charset="-122"/>
                 <a:cs typeface="Pretendard" pitchFamily="34" charset="-120"/>
               </a:rPr>
-              <a:t>World Model shared provenance log with a per-run JSONL audit;</a:t>
+              <a:t>Meterless Nightshift is the primary AI</a:t>
             </a:r>
             <a:endParaRPr lang="en-US" sz="1300" dirty="0"/>
           </a:p>
@@ -11155,7 +11876,7 @@
                 <a:ea typeface="Pretendard" pitchFamily="34" charset="-122"/>
                 <a:cs typeface="Pretendard" pitchFamily="34" charset="-120"/>
               </a:rPr>
-              <a:t>Markovian chunked county loop, conformance-tested, with</a:t>
+              <a:t>provider; model and compute receipt per</a:t>
             </a:r>
             <a:endParaRPr lang="en-US" sz="1300" dirty="0"/>
           </a:p>
@@ -11175,7 +11896,7 @@
                 <a:ea typeface="Pretendard" pitchFamily="34" charset="-122"/>
                 <a:cs typeface="Pretendard" pitchFamily="34" charset="-120"/>
               </a:rPr>
-              <a:t>0 tokens saved on current single-chunk sources.</a:t>
+              <a:t>request appear in the UI agent lanes.</a:t>
             </a:r>
             <a:endParaRPr lang="en-US" sz="1300" dirty="0"/>
           </a:p>
@@ -11189,7 +11910,7 @@
         </p:nvSpPr>
         <p:spPr>
           <a:xfrm>
-            <a:off x="6248400" y="4482783"/>
+            <a:off x="8229600" y="4306888"/>
             <a:ext cx="50800" cy="50800"/>
           </a:xfrm>
           <a:prstGeom prst="rect">
@@ -11209,8 +11930,8 @@
         </p:nvSpPr>
         <p:spPr>
           <a:xfrm>
-            <a:off x="6426200" y="4404995"/>
-            <a:ext cx="5461000" cy="206375"/>
+            <a:off x="8407400" y="4229100"/>
+            <a:ext cx="3479800" cy="1031875"/>
           </a:xfrm>
           <a:prstGeom prst="rect">
             <a:avLst/>
@@ -11237,22 +11958,122 @@
                 <a:ea typeface="Pretendard" pitchFamily="34" charset="-122"/>
                 <a:cs typeface="Pretendard" pitchFamily="34" charset="-120"/>
               </a:rPr>
-              <a:t>Cursor: &lt;to confirm&gt;</a:t>
+              <a:t>World Model shared provenance log with a</a:t>
             </a:r>
             <a:endParaRPr lang="en-US" sz="1300" dirty="0"/>
           </a:p>
+          <a:p>
+            <a:pPr algn="l" indent="0" marL="0">
+              <a:lnSpc>
+                <a:spcPts val="1630"/>
+              </a:lnSpc>
+              <a:buNone/>
+            </a:pPr>
+            <a:r>
+              <a:rPr lang="en-US" sz="1300" dirty="0">
+                <a:solidFill>
+                  <a:srgbClr val="15131A"/>
+                </a:solidFill>
+                <a:latin typeface="Pretendard" pitchFamily="34" charset="0"/>
+                <a:ea typeface="Pretendard" pitchFamily="34" charset="-122"/>
+                <a:cs typeface="Pretendard" pitchFamily="34" charset="-120"/>
+              </a:rPr>
+              <a:t>per-run JSONL audit; Markovian chunked</a:t>
+            </a:r>
+            <a:endParaRPr lang="en-US" sz="1300" dirty="0"/>
+          </a:p>
+          <a:p>
+            <a:pPr algn="l" indent="0" marL="0">
+              <a:lnSpc>
+                <a:spcPts val="1630"/>
+              </a:lnSpc>
+              <a:buNone/>
+            </a:pPr>
+            <a:r>
+              <a:rPr lang="en-US" sz="1300" dirty="0">
+                <a:solidFill>
+                  <a:srgbClr val="15131A"/>
+                </a:solidFill>
+                <a:latin typeface="Pretendard" pitchFamily="34" charset="0"/>
+                <a:ea typeface="Pretendard" pitchFamily="34" charset="-122"/>
+                <a:cs typeface="Pretendard" pitchFamily="34" charset="-120"/>
+              </a:rPr>
+              <a:t>county loop, conformance-tested, with</a:t>
+            </a:r>
+            <a:endParaRPr lang="en-US" sz="1300" dirty="0"/>
+          </a:p>
+          <a:p>
+            <a:pPr algn="l" indent="0" marL="0">
+              <a:lnSpc>
+                <a:spcPts val="1630"/>
+              </a:lnSpc>
+              <a:buNone/>
+            </a:pPr>
+            <a:r>
+              <a:rPr lang="en-US" sz="1300" dirty="0">
+                <a:solidFill>
+                  <a:srgbClr val="15131A"/>
+                </a:solidFill>
+                <a:latin typeface="Pretendard" pitchFamily="34" charset="0"/>
+                <a:ea typeface="Pretendard" pitchFamily="34" charset="-122"/>
+                <a:cs typeface="Pretendard" pitchFamily="34" charset="-120"/>
+              </a:rPr>
+              <a:t>0 tokens saved on current</a:t>
+            </a:r>
+            <a:endParaRPr lang="en-US" sz="1300" dirty="0"/>
+          </a:p>
+          <a:p>
+            <a:pPr algn="l" indent="0" marL="0">
+              <a:lnSpc>
+                <a:spcPts val="1630"/>
+              </a:lnSpc>
+              <a:buNone/>
+            </a:pPr>
+            <a:r>
+              <a:rPr lang="en-US" sz="1300" dirty="0">
+                <a:solidFill>
+                  <a:srgbClr val="15131A"/>
+                </a:solidFill>
+                <a:latin typeface="Pretendard" pitchFamily="34" charset="0"/>
+                <a:ea typeface="Pretendard" pitchFamily="34" charset="-122"/>
+                <a:cs typeface="Pretendard" pitchFamily="34" charset="-120"/>
+              </a:rPr>
+              <a:t>single-chunk sources.</a:t>
+            </a:r>
+            <a:endParaRPr lang="en-US" sz="1300" dirty="0"/>
+          </a:p>
         </p:txBody>
       </p:sp>
       <p:sp>
         <p:nvSpPr>
-          <p:cNvPr id="13" name="Text 10"/>
-          <p:cNvSpPr/>
-          <p:nvPr/>
-        </p:nvSpPr>
-        <p:spPr>
-          <a:xfrm>
-            <a:off x="304800" y="6023610"/>
-            <a:ext cx="11582400" cy="148590"/>
+          <p:cNvPr id="13" name="Shape 10"/>
+          <p:cNvSpPr/>
+          <p:nvPr/>
+        </p:nvSpPr>
+        <p:spPr>
+          <a:xfrm>
+            <a:off x="8229600" y="5414963"/>
+            <a:ext cx="50800" cy="50800"/>
+          </a:xfrm>
+          <a:prstGeom prst="rect">
+            <a:avLst/>
+          </a:prstGeom>
+          <a:solidFill>
+            <a:srgbClr val="C8361A"/>
+          </a:solidFill>
+          <a:ln/>
+        </p:spPr>
+      </p:sp>
+      <p:sp>
+        <p:nvSpPr>
+          <p:cNvPr id="14" name="Text 11"/>
+          <p:cNvSpPr/>
+          <p:nvPr/>
+        </p:nvSpPr>
+        <p:spPr>
+          <a:xfrm>
+            <a:off x="8407400" y="5337175"/>
+            <a:ext cx="3479800" cy="206375"/>
           </a:xfrm>
           <a:prstGeom prst="rect">
             <a:avLst/>
@@ -11266,6 +12087,48 @@
           <a:p>
             <a:pPr algn="l" indent="0" marL="0">
               <a:lnSpc>
+                <a:spcPts val="1630"/>
+              </a:lnSpc>
+              <a:buNone/>
+            </a:pPr>
+            <a:r>
+              <a:rPr lang="en-US" sz="1300" dirty="0">
+                <a:solidFill>
+                  <a:srgbClr val="15131A"/>
+                </a:solidFill>
+                <a:latin typeface="Pretendard" pitchFamily="34" charset="0"/>
+                <a:ea typeface="Pretendard" pitchFamily="34" charset="-122"/>
+                <a:cs typeface="Pretendard" pitchFamily="34" charset="-120"/>
+              </a:rPr>
+              <a:t>Cursor: &lt;to confirm&gt;</a:t>
+            </a:r>
+            <a:endParaRPr lang="en-US" sz="1300" dirty="0"/>
+          </a:p>
+        </p:txBody>
+      </p:sp>
+      <p:sp>
+        <p:nvSpPr>
+          <p:cNvPr id="15" name="Text 12"/>
+          <p:cNvSpPr/>
+          <p:nvPr/>
+        </p:nvSpPr>
+        <p:spPr>
+          <a:xfrm>
+            <a:off x="304800" y="6023610"/>
+            <a:ext cx="11582400" cy="148590"/>
+          </a:xfrm>
+          <a:prstGeom prst="rect">
+            <a:avLst/>
+          </a:prstGeom>
+          <a:noFill/>
+          <a:ln/>
+        </p:spPr>
+        <p:txBody>
+          <a:bodyPr wrap="square" lIns="0" tIns="0" rIns="0" bIns="0" rtlCol="0" anchor="t"/>
+          <a:lstStyle/>
+          <a:p>
+            <a:pPr algn="l" indent="0" marL="0">
+              <a:lnSpc>
                 <a:spcPts val="1130"/>
               </a:lnSpc>
               <a:buNone/>
@@ -11279,7 +12142,7 @@
                 <a:ea typeface="Pretendard" pitchFamily="34" charset="-122"/>
                 <a:cs typeface="Pretendard" pitchFamily="34" charset="-120"/>
               </a:rPr>
-              <a:t>Source: zetaris/usl.sql; zetaris/evidence/registration.json, run.json, dq_rule.json; zetaris/REFLECTION.md</a:t>
+              <a:t>Source: app/screen.py; app/orchestrator.py; zetaris/evidence/registration.json, run.json, dq_rule.json</a:t>
             </a:r>
             <a:endParaRPr lang="en-US" sz="900" dirty="0"/>
           </a:p>
@@ -11287,7 +12150,7 @@
       </p:sp>
       <p:sp>
         <p:nvSpPr>
-          <p:cNvPr id="14" name="title@top-plain-large"/>
+          <p:cNvPr id="16" name="title@top-plain-large"/>
           <p:cNvSpPr/>
           <p:nvPr/>
         </p:nvSpPr>
@@ -12705,7 +13568,7 @@
         </p:nvSpPr>
         <p:spPr>
           <a:xfrm>
-            <a:off x="304800" y="4080193"/>
+            <a:off x="304800" y="4232592"/>
             <a:ext cx="50800" cy="50800"/>
           </a:xfrm>
           <a:prstGeom prst="rect">
@@ -12725,8 +13588,8 @@
         </p:nvSpPr>
         <p:spPr>
           <a:xfrm>
-            <a:off x="482600" y="4002405"/>
-            <a:ext cx="8432800" cy="412750"/>
+            <a:off x="482600" y="4154805"/>
+            <a:ext cx="5461000" cy="412750"/>
           </a:xfrm>
           <a:prstGeom prst="rect">
             <a:avLst/>
@@ -12753,7 +13616,7 @@
                 <a:ea typeface="Pretendard" pitchFamily="34" charset="-122"/>
                 <a:cs typeface="Pretendard" pitchFamily="34" charset="-120"/>
               </a:rPr>
-              <a:t>Markovian saved 0 tokens on current sources; the engine and its accounting are implemented</a:t>
+              <a:t>Markovian saved 0 tokens on current sources; the engine and its</a:t>
             </a:r>
             <a:endParaRPr lang="en-US" sz="1300" dirty="0"/>
           </a:p>
@@ -12773,7 +13636,7 @@
                 <a:ea typeface="Pretendard" pitchFamily="34" charset="-122"/>
                 <a:cs typeface="Pretendard" pitchFamily="34" charset="-120"/>
               </a:rPr>
-              <a:t>and tested.</a:t>
+              <a:t>accounting are implemented and tested.</a:t>
             </a:r>
             <a:endParaRPr lang="en-US" sz="1300" dirty="0"/>
           </a:p>
@@ -12787,7 +13650,7 @@
         </p:nvSpPr>
         <p:spPr>
           <a:xfrm>
-            <a:off x="304800" y="4569142"/>
+            <a:off x="304800" y="4797742"/>
             <a:ext cx="50800" cy="50800"/>
           </a:xfrm>
           <a:prstGeom prst="rect">
@@ -12807,8 +13670,8 @@
         </p:nvSpPr>
         <p:spPr>
           <a:xfrm>
-            <a:off x="482600" y="4491355"/>
-            <a:ext cx="8432800" cy="206375"/>
+            <a:off x="482600" y="4719955"/>
+            <a:ext cx="5461000" cy="412750"/>
           </a:xfrm>
           <a:prstGeom prst="rect">
             <a:avLst/>
@@ -12835,10 +13698,30 @@
                 <a:ea typeface="Pretendard" pitchFamily="34" charset="-122"/>
                 <a:cs typeface="Pretendard" pitchFamily="34" charset="-120"/>
               </a:rPr>
-              <a:t>Seed rules are curated with runtime-verified quotes; autonomous rule discovery is roadmap.</a:t>
+              <a:t>Seed rules are curated with runtime-verified quotes; autonomous</a:t>
             </a:r>
             <a:endParaRPr lang="en-US" sz="1300" dirty="0"/>
           </a:p>
+          <a:p>
+            <a:pPr algn="l" indent="0" marL="0">
+              <a:lnSpc>
+                <a:spcPts val="1630"/>
+              </a:lnSpc>
+              <a:buNone/>
+            </a:pPr>
+            <a:r>
+              <a:rPr lang="en-US" sz="1300" dirty="0">
+                <a:solidFill>
+                  <a:srgbClr val="15131A"/>
+                </a:solidFill>
+                <a:latin typeface="Pretendard" pitchFamily="34" charset="0"/>
+                <a:ea typeface="Pretendard" pitchFamily="34" charset="-122"/>
+                <a:cs typeface="Pretendard" pitchFamily="34" charset="-120"/>
+              </a:rPr>
+              <a:t>rule discovery is roadmap.</a:t>
+            </a:r>
+            <a:endParaRPr lang="en-US" sz="1300" dirty="0"/>
+          </a:p>
         </p:txBody>
       </p:sp>
       <p:sp>
@@ -12849,7 +13732,7 @@
         </p:nvSpPr>
         <p:spPr>
           <a:xfrm>
-            <a:off x="304800" y="4851718"/>
+            <a:off x="6248400" y="4232592"/>
             <a:ext cx="50800" cy="50800"/>
           </a:xfrm>
           <a:prstGeom prst="rect">
@@ -12869,8 +13752,8 @@
         </p:nvSpPr>
         <p:spPr>
           <a:xfrm>
-            <a:off x="482600" y="4773930"/>
-            <a:ext cx="8432800" cy="412750"/>
+            <a:off x="6426200" y="4154805"/>
+            <a:ext cx="5461000" cy="412750"/>
           </a:xfrm>
           <a:prstGeom prst="rect">
             <a:avLst/>
@@ -12897,7 +13780,7 @@
                 <a:ea typeface="Pretendard" pitchFamily="34" charset="-122"/>
                 <a:cs typeface="Pretendard" pitchFamily="34" charset="-120"/>
               </a:rPr>
-              <a:t>Coverage is modelled for Texas and ERCOT plus two counties; other states get a federal-only report</a:t>
+              <a:t>Coverage is modelled for Texas and ERCOT plus two counties; other</a:t>
             </a:r>
             <a:endParaRPr lang="en-US" sz="1300" dirty="0"/>
           </a:p>
@@ -12917,7 +13800,7 @@
                 <a:ea typeface="Pretendard" pitchFamily="34" charset="-122"/>
                 <a:cs typeface="Pretendard" pitchFamily="34" charset="-120"/>
               </a:rPr>
-              <a:t>with an explicit scope note.</a:t>
+              <a:t>states get a federal-only report with an explicit scope note.</a:t>
             </a:r>
             <a:endParaRPr lang="en-US" sz="1300" dirty="0"/>
           </a:p>
@@ -12925,14 +13808,34 @@
       </p:sp>
       <p:sp>
         <p:nvSpPr>
-          <p:cNvPr id="12" name="Text 9"/>
-          <p:cNvSpPr/>
-          <p:nvPr/>
-        </p:nvSpPr>
-        <p:spPr>
-          <a:xfrm>
-            <a:off x="304800" y="6023610"/>
-            <a:ext cx="11582400" cy="148590"/>
+          <p:cNvPr id="12" name="Shape 9"/>
+          <p:cNvSpPr/>
+          <p:nvPr/>
+        </p:nvSpPr>
+        <p:spPr>
+          <a:xfrm>
+            <a:off x="6248400" y="4797742"/>
+            <a:ext cx="50800" cy="50800"/>
+          </a:xfrm>
+          <a:prstGeom prst="rect">
+            <a:avLst/>
+          </a:prstGeom>
+          <a:solidFill>
+            <a:srgbClr val="C8361A"/>
+          </a:solidFill>
+          <a:ln/>
+        </p:spPr>
+      </p:sp>
+      <p:sp>
+        <p:nvSpPr>
+          <p:cNvPr id="13" name="Text 10"/>
+          <p:cNvSpPr/>
+          <p:nvPr/>
+        </p:nvSpPr>
+        <p:spPr>
+          <a:xfrm>
+            <a:off x="6426200" y="4719955"/>
+            <a:ext cx="5461000" cy="412750"/>
           </a:xfrm>
           <a:prstGeom prst="rect">
             <a:avLst/>
@@ -12946,6 +13849,68 @@
           <a:p>
             <a:pPr algn="l" indent="0" marL="0">
               <a:lnSpc>
+                <a:spcPts val="1630"/>
+              </a:lnSpc>
+              <a:buNone/>
+            </a:pPr>
+            <a:r>
+              <a:rPr lang="en-US" sz="1300" dirty="0">
+                <a:solidFill>
+                  <a:srgbClr val="15131A"/>
+                </a:solidFill>
+                <a:latin typeface="Pretendard" pitchFamily="34" charset="0"/>
+                <a:ea typeface="Pretendard" pitchFamily="34" charset="-122"/>
+                <a:cs typeface="Pretendard" pitchFamily="34" charset="-120"/>
+              </a:rPr>
+              <a:t>Sample mode replays recorded model answers while the agent</a:t>
+            </a:r>
+            <a:endParaRPr lang="en-US" sz="1300" dirty="0"/>
+          </a:p>
+          <a:p>
+            <a:pPr algn="l" indent="0" marL="0">
+              <a:lnSpc>
+                <a:spcPts val="1630"/>
+              </a:lnSpc>
+              <a:buNone/>
+            </a:pPr>
+            <a:r>
+              <a:rPr lang="en-US" sz="1300" dirty="0">
+                <a:solidFill>
+                  <a:srgbClr val="15131A"/>
+                </a:solidFill>
+                <a:latin typeface="Pretendard" pitchFamily="34" charset="0"/>
+                <a:ea typeface="Pretendard" pitchFamily="34" charset="-122"/>
+                <a:cs typeface="Pretendard" pitchFamily="34" charset="-120"/>
+              </a:rPr>
+              <a:t>logic runs for real.</a:t>
+            </a:r>
+            <a:endParaRPr lang="en-US" sz="1300" dirty="0"/>
+          </a:p>
+        </p:txBody>
+      </p:sp>
+      <p:sp>
+        <p:nvSpPr>
+          <p:cNvPr id="14" name="Text 11"/>
+          <p:cNvSpPr/>
+          <p:nvPr/>
+        </p:nvSpPr>
+        <p:spPr>
+          <a:xfrm>
+            <a:off x="304800" y="6023610"/>
+            <a:ext cx="11582400" cy="148590"/>
+          </a:xfrm>
+          <a:prstGeom prst="rect">
+            <a:avLst/>
+          </a:prstGeom>
+          <a:noFill/>
+          <a:ln/>
+        </p:spPr>
+        <p:txBody>
+          <a:bodyPr wrap="square" lIns="0" tIns="0" rIns="0" bIns="0" rtlCol="0" anchor="t"/>
+          <a:lstStyle/>
+          <a:p>
+            <a:pPr algn="l" indent="0" marL="0">
+              <a:lnSpc>
                 <a:spcPts val="1130"/>
               </a:lnSpc>
               <a:buNone/>
@@ -12959,7 +13924,7 @@
                 <a:ea typeface="Pretendard" pitchFamily="34" charset="-122"/>
                 <a:cs typeface="Pretendard" pitchFamily="34" charset="-120"/>
               </a:rPr>
-              <a:t>Source: data/eval/results.json; README limitations</a:t>
+              <a:t>Source: data/eval/results.json; README limitations; app/llm.py cache replay</a:t>
             </a:r>
             <a:endParaRPr lang="en-US" sz="900" dirty="0"/>
           </a:p>
@@ -12967,7 +13932,7 @@
       </p:sp>
       <p:sp>
         <p:nvSpPr>
-          <p:cNvPr id="13" name="title@top-rule"/>
+          <p:cNvPr id="15" name="title@top-rule"/>
           <p:cNvSpPr/>
           <p:nvPr/>
         </p:nvSpPr>

</xml_diff>

<commit_message>
docs(submission): Cursor line and investigator wording
</commit_message>
<xml_diff>
--- a/submission/deck/sitewhy-deck.pptx
+++ b/submission/deck/sitewhy-deck.pptx
@@ -10617,7 +10617,7 @@
         <p:spPr>
           <a:xfrm>
             <a:off x="482600" y="4342765"/>
-            <a:ext cx="8432800" cy="412750"/>
+            <a:ext cx="5461000" cy="412750"/>
           </a:xfrm>
           <a:prstGeom prst="rect">
             <a:avLst/>
@@ -10644,7 +10644,7 @@
                 <a:ea typeface="Pretendard" pitchFamily="34" charset="-122"/>
                 <a:cs typeface="Pretendard" pitchFamily="34" charset="-120"/>
               </a:rPr>
-              <a:t>One run at a time; a run past its deadline returns a partial needs_confirmation report instead</a:t>
+              <a:t>One run at a time; a run past its deadline returns a partial</a:t>
             </a:r>
             <a:endParaRPr lang="en-US" sz="1300" dirty="0"/>
           </a:p>
@@ -10664,7 +10664,7 @@
                 <a:ea typeface="Pretendard" pitchFamily="34" charset="-122"/>
                 <a:cs typeface="Pretendard" pitchFamily="34" charset="-120"/>
               </a:rPr>
-              <a:t>of hanging.</a:t>
+              <a:t>needs_confirmation report instead of hanging.</a:t>
             </a:r>
             <a:endParaRPr lang="en-US" sz="1300" dirty="0"/>
           </a:p>
@@ -10699,7 +10699,7 @@
         <p:spPr>
           <a:xfrm>
             <a:off x="482600" y="4831715"/>
-            <a:ext cx="8432800" cy="206375"/>
+            <a:ext cx="5461000" cy="206375"/>
           </a:xfrm>
           <a:prstGeom prst="rect">
             <a:avLst/>
@@ -10740,7 +10740,7 @@
         </p:nvSpPr>
         <p:spPr>
           <a:xfrm>
-            <a:off x="304800" y="5192078"/>
+            <a:off x="6248400" y="4420553"/>
             <a:ext cx="50800" cy="50800"/>
           </a:xfrm>
           <a:prstGeom prst="rect">
@@ -10760,8 +10760,8 @@
         </p:nvSpPr>
         <p:spPr>
           <a:xfrm>
-            <a:off x="482600" y="5114290"/>
-            <a:ext cx="8432800" cy="412750"/>
+            <a:off x="6426200" y="4342765"/>
+            <a:ext cx="5461000" cy="412750"/>
           </a:xfrm>
           <a:prstGeom prst="rect">
             <a:avLst/>
@@ -10788,10 +10788,52 @@
                 <a:ea typeface="Pretendard" pitchFamily="34" charset="-122"/>
                 <a:cs typeface="Pretendard" pitchFamily="34" charset="-120"/>
               </a:rPr>
-              <a:t>Programmatic entry: python run.py --input input_examples/&lt;site&gt;.json --sample, with per-event</a:t>
+              <a:t>Programmatic entry: python run.py --input input_examples/&lt;site&gt;.json --sample, with per-event traces in logs/*.jsonl.</a:t>
             </a:r>
             <a:endParaRPr lang="en-US" sz="1300" dirty="0"/>
           </a:p>
+        </p:txBody>
+      </p:sp>
+      <p:sp>
+        <p:nvSpPr>
+          <p:cNvPr id="12" name="Shape 9"/>
+          <p:cNvSpPr/>
+          <p:nvPr/>
+        </p:nvSpPr>
+        <p:spPr>
+          <a:xfrm>
+            <a:off x="6248400" y="4909503"/>
+            <a:ext cx="50800" cy="50800"/>
+          </a:xfrm>
+          <a:prstGeom prst="rect">
+            <a:avLst/>
+          </a:prstGeom>
+          <a:solidFill>
+            <a:srgbClr val="C8361A"/>
+          </a:solidFill>
+          <a:ln/>
+        </p:spPr>
+      </p:sp>
+      <p:sp>
+        <p:nvSpPr>
+          <p:cNvPr id="13" name="Text 10"/>
+          <p:cNvSpPr/>
+          <p:nvPr/>
+        </p:nvSpPr>
+        <p:spPr>
+          <a:xfrm>
+            <a:off x="6426200" y="4831715"/>
+            <a:ext cx="5461000" cy="412750"/>
+          </a:xfrm>
+          <a:prstGeom prst="rect">
+            <a:avLst/>
+          </a:prstGeom>
+          <a:noFill/>
+          <a:ln/>
+        </p:spPr>
+        <p:txBody>
+          <a:bodyPr wrap="square" lIns="0" tIns="0" rIns="0" bIns="0" rtlCol="0" anchor="t"/>
+          <a:lstStyle/>
           <a:p>
             <a:pPr algn="l" indent="0" marL="0">
               <a:lnSpc>
@@ -10808,15 +10850,35 @@
                 <a:ea typeface="Pretendard" pitchFamily="34" charset="-122"/>
                 <a:cs typeface="Pretendard" pitchFamily="34" charset="-120"/>
               </a:rPr>
-              <a:t>traces in logs/*.jsonl.</a:t>
+              <a:t>Run with Docker: docker build -t sitewhy . &amp;&amp; docker run -p</a:t>
             </a:r>
             <a:endParaRPr lang="en-US" sz="1300" dirty="0"/>
           </a:p>
-        </p:txBody>
-      </p:sp>
-      <p:sp>
-        <p:nvSpPr>
-          <p:cNvPr id="12" name="Text 9"/>
+          <a:p>
+            <a:pPr algn="l" indent="0" marL="0">
+              <a:lnSpc>
+                <a:spcPts val="1630"/>
+              </a:lnSpc>
+              <a:buNone/>
+            </a:pPr>
+            <a:r>
+              <a:rPr lang="en-US" sz="1300" dirty="0">
+                <a:solidFill>
+                  <a:srgbClr val="15131A"/>
+                </a:solidFill>
+                <a:latin typeface="Pretendard" pitchFamily="34" charset="0"/>
+                <a:ea typeface="Pretendard" pitchFamily="34" charset="-122"/>
+                <a:cs typeface="Pretendard" pitchFamily="34" charset="-120"/>
+              </a:rPr>
+              <a:t>8000:8000 sitewhy.</a:t>
+            </a:r>
+            <a:endParaRPr lang="en-US" sz="1300" dirty="0"/>
+          </a:p>
+        </p:txBody>
+      </p:sp>
+      <p:sp>
+        <p:nvSpPr>
+          <p:cNvPr id="14" name="Text 11"/>
           <p:cNvSpPr/>
           <p:nvPr/>
         </p:nvSpPr>
@@ -10858,7 +10920,7 @@
       </p:sp>
       <p:sp>
         <p:nvSpPr>
-          <p:cNvPr id="13" name="title@top-rule"/>
+          <p:cNvPr id="15" name="title@top-rule"/>
           <p:cNvSpPr/>
           <p:nvPr/>
         </p:nvSpPr>
@@ -10966,16 +11028,16 @@
         </p:nvGraphicFramePr>
         <p:xfrm>
           <a:off x="304800" y="1524000"/>
-          <a:ext cx="7620000" cy="1470025"/>
+          <a:ext cx="11582400" cy="1064895"/>
         </p:xfrm>
         <a:graphic>
           <a:graphicData uri="http://schemas.openxmlformats.org/drawingml/2006/table">
             <a:tbl>
               <a:tblPr/>
               <a:tblGrid>
-                <a:gridCol w="1809065"/>
-                <a:gridCol w="2412086"/>
-                <a:gridCol w="3398849"/>
+                <a:gridCol w="2749778"/>
+                <a:gridCol w="3666371"/>
+                <a:gridCol w="5166250"/>
               </a:tblGrid>
               <a:tr h="354965">
                 <a:tc>
@@ -11138,7 +11200,7 @@
                   </a:tcPr>
                 </a:tc>
               </a:tr>
-              <a:tr h="557530">
+              <a:tr h="354965">
                 <a:tc>
                   <a:txBody>
                     <a:bodyPr/>
@@ -11156,28 +11218,7 @@
                           <a:ea typeface="Pretendard" pitchFamily="34" charset="-122"/>
                           <a:cs typeface="Pretendard" pitchFamily="34" charset="-120"/>
                         </a:rPr>
-                        <a:t>moratoria plus</a:t>
-                      </a:r>
-                      <a:endParaRPr lang="en-US" sz="1100" dirty="0">
-                        <a:latin typeface="Pretendard" charset="0"/>
-                        <a:ea typeface="Pretendard" charset="0"/>
-                        <a:cs typeface="Pretendard" charset="0"/>
-                      </a:endParaRPr>
-                    </a:p>
-                    <a:p>
-                      <a:pPr algn="l" indent="0" marL="0">
-                        <a:buNone/>
-                      </a:pPr>
-                      <a:r>
-                        <a:rPr lang="en-US" sz="1100" dirty="0">
-                          <a:solidFill>
-                            <a:srgbClr val="15131A"/>
-                          </a:solidFill>
-                          <a:latin typeface="Pretendard" pitchFamily="34" charset="0"/>
-                          <a:ea typeface="Pretendard" pitchFamily="34" charset="-122"/>
-                          <a:cs typeface="Pretendard" pitchFamily="34" charset="-120"/>
-                        </a:rPr>
-                        <a:t>state_legislation</a:t>
+                        <a:t>moratoria plus state_legislation</a:t>
                       </a:r>
                       <a:endParaRPr lang="en-US" sz="1100" dirty="0">
                         <a:latin typeface="Pretendard" charset="0"/>
@@ -11284,7 +11325,7 @@
                   </a:tcPr>
                 </a:tc>
               </a:tr>
-              <a:tr h="557530">
+              <a:tr h="354965">
                 <a:tc>
                   <a:txBody>
                     <a:bodyPr/>
@@ -11302,28 +11343,7 @@
                           <a:ea typeface="Pretendard" pitchFamily="34" charset="-122"/>
                           <a:cs typeface="Pretendard" pitchFamily="34" charset="-120"/>
                         </a:rPr>
-                        <a:t>queried by the agents</a:t>
-                      </a:r>
-                      <a:endParaRPr lang="en-US" sz="1100" dirty="0">
-                        <a:latin typeface="Pretendard" charset="0"/>
-                        <a:ea typeface="Pretendard" charset="0"/>
-                        <a:cs typeface="Pretendard" charset="0"/>
-                      </a:endParaRPr>
-                    </a:p>
-                    <a:p>
-                      <a:pPr algn="l" indent="0" marL="0">
-                        <a:buNone/>
-                      </a:pPr>
-                      <a:r>
-                        <a:rPr lang="en-US" sz="1100" dirty="0">
-                          <a:solidFill>
-                            <a:srgbClr val="15131A"/>
-                          </a:solidFill>
-                          <a:latin typeface="Pretendard" pitchFamily="34" charset="0"/>
-                          <a:ea typeface="Pretendard" pitchFamily="34" charset="-122"/>
-                          <a:cs typeface="Pretendard" pitchFamily="34" charset="-120"/>
-                        </a:rPr>
-                        <a:t>at run time</a:t>
+                        <a:t>queried by the agents at run time</a:t>
                       </a:r>
                       <a:endParaRPr lang="en-US" sz="1100" dirty="0">
                         <a:latin typeface="Pretendard" charset="0"/>
@@ -11370,28 +11390,7 @@
                           <a:ea typeface="Pretendard" pitchFamily="34" charset="-122"/>
                           <a:cs typeface="Pretendard" pitchFamily="34" charset="-120"/>
                         </a:rPr>
-                        <a:t>usl_site_screen from 4 seed</a:t>
-                      </a:r>
-                      <a:endParaRPr lang="en-US" sz="1100" dirty="0">
-                        <a:latin typeface="Pretendard" charset="0"/>
-                        <a:ea typeface="Pretendard" charset="0"/>
-                        <a:cs typeface="Pretendard" charset="0"/>
-                      </a:endParaRPr>
-                    </a:p>
-                    <a:p>
-                      <a:pPr algn="l" indent="0" marL="0">
-                        <a:buNone/>
-                      </a:pPr>
-                      <a:r>
-                        <a:rPr lang="en-US" sz="1100" dirty="0">
-                          <a:solidFill>
-                            <a:srgbClr val="15131A"/>
-                          </a:solidFill>
-                          <a:latin typeface="Pretendard" pitchFamily="34" charset="0"/>
-                          <a:ea typeface="Pretendard" pitchFamily="34" charset="-122"/>
-                          <a:cs typeface="Pretendard" pitchFamily="34" charset="-120"/>
-                        </a:rPr>
-                        <a:t>tables, scripted</a:t>
+                        <a:t>usl_site_screen from 4 seed tables, scripted</a:t>
                       </a:r>
                       <a:endParaRPr lang="en-US" sz="1100" dirty="0">
                         <a:latin typeface="Pretendard" charset="0"/>
@@ -11438,28 +11437,7 @@
                           <a:ea typeface="Pretendard" pitchFamily="34" charset="-122"/>
                           <a:cs typeface="Pretendard" pitchFamily="34" charset="-120"/>
                         </a:rPr>
-                        <a:t>12 exploratory plus 3 USL queries;</a:t>
-                      </a:r>
-                      <a:endParaRPr lang="en-US" sz="1100" dirty="0">
-                        <a:latin typeface="Pretendard" charset="0"/>
-                        <a:ea typeface="Pretendard" charset="0"/>
-                        <a:cs typeface="Pretendard" charset="0"/>
-                      </a:endParaRPr>
-                    </a:p>
-                    <a:p>
-                      <a:pPr algn="l" indent="0" marL="0">
-                        <a:buNone/>
-                      </a:pPr>
-                      <a:r>
-                        <a:rPr lang="en-US" sz="1100" dirty="0">
-                          <a:solidFill>
-                            <a:srgbClr val="15131A"/>
-                          </a:solidFill>
-                          <a:latin typeface="Pretendard" pitchFamily="34" charset="0"/>
-                          <a:ea typeface="Pretendard" pitchFamily="34" charset="-122"/>
-                          <a:cs typeface="Pretendard" pitchFamily="34" charset="-120"/>
-                        </a:rPr>
-                        <a:t>null_join_keys 0 violations</a:t>
+                        <a:t>12 exploratory plus 3 USL queries; null_join_keys 0 violations</a:t>
                       </a:r>
                       <a:endParaRPr lang="en-US" sz="1100" dirty="0">
                         <a:latin typeface="Pretendard" charset="0"/>
@@ -11502,8 +11480,8 @@
         </p:nvSpPr>
         <p:spPr>
           <a:xfrm>
-            <a:off x="304800" y="3070225"/>
-            <a:ext cx="7620000" cy="181610"/>
+            <a:off x="304800" y="2665095"/>
+            <a:ext cx="11582400" cy="181610"/>
           </a:xfrm>
           <a:prstGeom prst="rect">
             <a:avLst/>
@@ -11544,7 +11522,7 @@
         </p:nvSpPr>
         <p:spPr>
           <a:xfrm>
-            <a:off x="8229600" y="1601788"/>
+            <a:off x="304800" y="3153092"/>
             <a:ext cx="50800" cy="50800"/>
           </a:xfrm>
           <a:prstGeom prst="rect">
@@ -11564,8 +11542,8 @@
         </p:nvSpPr>
         <p:spPr>
           <a:xfrm>
-            <a:off x="8407400" y="1524000"/>
-            <a:ext cx="3479800" cy="1031875"/>
+            <a:off x="482600" y="3075305"/>
+            <a:ext cx="8432800" cy="412750"/>
           </a:xfrm>
           <a:prstGeom prst="rect">
             <a:avLst/>
@@ -11592,7 +11570,7 @@
                 <a:ea typeface="Pretendard" pitchFamily="34" charset="-122"/>
                 <a:cs typeface="Pretendard" pitchFamily="34" charset="-120"/>
               </a:rPr>
-              <a:t>Zetaris is the data layer: the agents</a:t>
+              <a:t>Zetaris is the data layer: the agents query SITEWHY.moratoria and SITEWHY.state_legislation at</a:t>
             </a:r>
             <a:endParaRPr lang="en-US" sz="1300" dirty="0"/>
           </a:p>
@@ -11612,70 +11590,10 @@
                 <a:ea typeface="Pretendard" pitchFamily="34" charset="-122"/>
                 <a:cs typeface="Pretendard" pitchFamily="34" charset="-120"/>
               </a:rPr>
-              <a:t>query SITEWHY.moratoria and</a:t>
+              <a:t>run time; DuckDB serves the same SQL when Zetaris is unreachable.</a:t>
             </a:r>
             <a:endParaRPr lang="en-US" sz="1300" dirty="0"/>
           </a:p>
-          <a:p>
-            <a:pPr algn="l" indent="0" marL="0">
-              <a:lnSpc>
-                <a:spcPts val="1630"/>
-              </a:lnSpc>
-              <a:buNone/>
-            </a:pPr>
-            <a:r>
-              <a:rPr lang="en-US" sz="1300" dirty="0">
-                <a:solidFill>
-                  <a:srgbClr val="15131A"/>
-                </a:solidFill>
-                <a:latin typeface="Pretendard" pitchFamily="34" charset="0"/>
-                <a:ea typeface="Pretendard" pitchFamily="34" charset="-122"/>
-                <a:cs typeface="Pretendard" pitchFamily="34" charset="-120"/>
-              </a:rPr>
-              <a:t>SITEWHY.state_legislation at run time;</a:t>
-            </a:r>
-            <a:endParaRPr lang="en-US" sz="1300" dirty="0"/>
-          </a:p>
-          <a:p>
-            <a:pPr algn="l" indent="0" marL="0">
-              <a:lnSpc>
-                <a:spcPts val="1630"/>
-              </a:lnSpc>
-              <a:buNone/>
-            </a:pPr>
-            <a:r>
-              <a:rPr lang="en-US" sz="1300" dirty="0">
-                <a:solidFill>
-                  <a:srgbClr val="15131A"/>
-                </a:solidFill>
-                <a:latin typeface="Pretendard" pitchFamily="34" charset="0"/>
-                <a:ea typeface="Pretendard" pitchFamily="34" charset="-122"/>
-                <a:cs typeface="Pretendard" pitchFamily="34" charset="-120"/>
-              </a:rPr>
-              <a:t>DuckDB serves the same SQL when Zetaris</a:t>
-            </a:r>
-            <a:endParaRPr lang="en-US" sz="1300" dirty="0"/>
-          </a:p>
-          <a:p>
-            <a:pPr algn="l" indent="0" marL="0">
-              <a:lnSpc>
-                <a:spcPts val="1630"/>
-              </a:lnSpc>
-              <a:buNone/>
-            </a:pPr>
-            <a:r>
-              <a:rPr lang="en-US" sz="1300" dirty="0">
-                <a:solidFill>
-                  <a:srgbClr val="15131A"/>
-                </a:solidFill>
-                <a:latin typeface="Pretendard" pitchFamily="34" charset="0"/>
-                <a:ea typeface="Pretendard" pitchFamily="34" charset="-122"/>
-                <a:cs typeface="Pretendard" pitchFamily="34" charset="-120"/>
-              </a:rPr>
-              <a:t>is unreachable.</a:t>
-            </a:r>
-            <a:endParaRPr lang="en-US" sz="1300" dirty="0"/>
-          </a:p>
         </p:txBody>
       </p:sp>
       <p:sp>
@@ -11686,7 +11604,7 @@
         </p:nvSpPr>
         <p:spPr>
           <a:xfrm>
-            <a:off x="8229600" y="2709863"/>
+            <a:off x="304800" y="3642043"/>
             <a:ext cx="50800" cy="50800"/>
           </a:xfrm>
           <a:prstGeom prst="rect">
@@ -11706,8 +11624,8 @@
         </p:nvSpPr>
         <p:spPr>
           <a:xfrm>
-            <a:off x="8407400" y="2632075"/>
-            <a:ext cx="3479800" cy="825500"/>
+            <a:off x="482600" y="3564255"/>
+            <a:ext cx="8432800" cy="412750"/>
           </a:xfrm>
           <a:prstGeom prst="rect">
             <a:avLst/>
@@ -11734,7 +11652,7 @@
                 <a:ea typeface="Pretendard" pitchFamily="34" charset="-122"/>
                 <a:cs typeface="Pretendard" pitchFamily="34" charset="-120"/>
               </a:rPr>
-              <a:t>The USL is a separate scripted artifact,</a:t>
+              <a:t>The USL is a separate scripted artifact, materialized because plain views do not persist on this</a:t>
             </a:r>
             <a:endParaRPr lang="en-US" sz="1300" dirty="0"/>
           </a:p>
@@ -11754,50 +11672,10 @@
                 <a:ea typeface="Pretendard" pitchFamily="34" charset="-122"/>
                 <a:cs typeface="Pretendard" pitchFamily="34" charset="-120"/>
               </a:rPr>
-              <a:t>materialized because plain views do not</a:t>
+              <a:t>instance — evidence the same joins hold, not yet on the agent path.</a:t>
             </a:r>
             <a:endParaRPr lang="en-US" sz="1300" dirty="0"/>
           </a:p>
-          <a:p>
-            <a:pPr algn="l" indent="0" marL="0">
-              <a:lnSpc>
-                <a:spcPts val="1630"/>
-              </a:lnSpc>
-              <a:buNone/>
-            </a:pPr>
-            <a:r>
-              <a:rPr lang="en-US" sz="1300" dirty="0">
-                <a:solidFill>
-                  <a:srgbClr val="15131A"/>
-                </a:solidFill>
-                <a:latin typeface="Pretendard" pitchFamily="34" charset="0"/>
-                <a:ea typeface="Pretendard" pitchFamily="34" charset="-122"/>
-                <a:cs typeface="Pretendard" pitchFamily="34" charset="-120"/>
-              </a:rPr>
-              <a:t>persist on this instance — evidence the</a:t>
-            </a:r>
-            <a:endParaRPr lang="en-US" sz="1300" dirty="0"/>
-          </a:p>
-          <a:p>
-            <a:pPr algn="l" indent="0" marL="0">
-              <a:lnSpc>
-                <a:spcPts val="1630"/>
-              </a:lnSpc>
-              <a:buNone/>
-            </a:pPr>
-            <a:r>
-              <a:rPr lang="en-US" sz="1300" dirty="0">
-                <a:solidFill>
-                  <a:srgbClr val="15131A"/>
-                </a:solidFill>
-                <a:latin typeface="Pretendard" pitchFamily="34" charset="0"/>
-                <a:ea typeface="Pretendard" pitchFamily="34" charset="-122"/>
-                <a:cs typeface="Pretendard" pitchFamily="34" charset="-120"/>
-              </a:rPr>
-              <a:t>same joins hold, not yet on the agent path.</a:t>
-            </a:r>
-            <a:endParaRPr lang="en-US" sz="1300" dirty="0"/>
-          </a:p>
         </p:txBody>
       </p:sp>
       <p:sp>
@@ -11808,7 +11686,7 @@
         </p:nvSpPr>
         <p:spPr>
           <a:xfrm>
-            <a:off x="8229600" y="3611563"/>
+            <a:off x="304800" y="4130993"/>
             <a:ext cx="50800" cy="50800"/>
           </a:xfrm>
           <a:prstGeom prst="rect">
@@ -11828,8 +11706,8 @@
         </p:nvSpPr>
         <p:spPr>
           <a:xfrm>
-            <a:off x="8407400" y="3533775"/>
-            <a:ext cx="3479800" cy="619125"/>
+            <a:off x="482600" y="4053205"/>
+            <a:ext cx="8432800" cy="412750"/>
           </a:xfrm>
           <a:prstGeom prst="rect">
             <a:avLst/>
@@ -11856,7 +11734,7 @@
                 <a:ea typeface="Pretendard" pitchFamily="34" charset="-122"/>
                 <a:cs typeface="Pretendard" pitchFamily="34" charset="-120"/>
               </a:rPr>
-              <a:t>Meterless Nightshift is the primary AI</a:t>
+              <a:t>Meterless Nightshift is the primary AI provider; model and compute receipt per request appear in</a:t>
             </a:r>
             <a:endParaRPr lang="en-US" sz="1300" dirty="0"/>
           </a:p>
@@ -11876,30 +11754,10 @@
                 <a:ea typeface="Pretendard" pitchFamily="34" charset="-122"/>
                 <a:cs typeface="Pretendard" pitchFamily="34" charset="-120"/>
               </a:rPr>
-              <a:t>provider; model and compute receipt per</a:t>
+              <a:t>the UI agent lanes.</a:t>
             </a:r>
             <a:endParaRPr lang="en-US" sz="1300" dirty="0"/>
           </a:p>
-          <a:p>
-            <a:pPr algn="l" indent="0" marL="0">
-              <a:lnSpc>
-                <a:spcPts val="1630"/>
-              </a:lnSpc>
-              <a:buNone/>
-            </a:pPr>
-            <a:r>
-              <a:rPr lang="en-US" sz="1300" dirty="0">
-                <a:solidFill>
-                  <a:srgbClr val="15131A"/>
-                </a:solidFill>
-                <a:latin typeface="Pretendard" pitchFamily="34" charset="0"/>
-                <a:ea typeface="Pretendard" pitchFamily="34" charset="-122"/>
-                <a:cs typeface="Pretendard" pitchFamily="34" charset="-120"/>
-              </a:rPr>
-              <a:t>request appear in the UI agent lanes.</a:t>
-            </a:r>
-            <a:endParaRPr lang="en-US" sz="1300" dirty="0"/>
-          </a:p>
         </p:txBody>
       </p:sp>
       <p:sp>
@@ -11910,7 +11768,7 @@
         </p:nvSpPr>
         <p:spPr>
           <a:xfrm>
-            <a:off x="8229600" y="4306888"/>
+            <a:off x="304800" y="4619943"/>
             <a:ext cx="50800" cy="50800"/>
           </a:xfrm>
           <a:prstGeom prst="rect">
@@ -11930,8 +11788,8 @@
         </p:nvSpPr>
         <p:spPr>
           <a:xfrm>
-            <a:off x="8407400" y="4229100"/>
-            <a:ext cx="3479800" cy="1031875"/>
+            <a:off x="482600" y="4542155"/>
+            <a:ext cx="8432800" cy="412750"/>
           </a:xfrm>
           <a:prstGeom prst="rect">
             <a:avLst/>
@@ -11958,7 +11816,7 @@
                 <a:ea typeface="Pretendard" pitchFamily="34" charset="-122"/>
                 <a:cs typeface="Pretendard" pitchFamily="34" charset="-120"/>
               </a:rPr>
-              <a:t>World Model shared provenance log with a</a:t>
+              <a:t>World Model shared provenance log with a per-run JSONL audit; Markovian chunked county loop,</a:t>
             </a:r>
             <a:endParaRPr lang="en-US" sz="1300" dirty="0"/>
           </a:p>
@@ -11978,70 +11836,10 @@
                 <a:ea typeface="Pretendard" pitchFamily="34" charset="-122"/>
                 <a:cs typeface="Pretendard" pitchFamily="34" charset="-120"/>
               </a:rPr>
-              <a:t>per-run JSONL audit; Markovian chunked</a:t>
+              <a:t>conformance-tested, with 0 tokens saved on current single-chunk sources.</a:t>
             </a:r>
             <a:endParaRPr lang="en-US" sz="1300" dirty="0"/>
           </a:p>
-          <a:p>
-            <a:pPr algn="l" indent="0" marL="0">
-              <a:lnSpc>
-                <a:spcPts val="1630"/>
-              </a:lnSpc>
-              <a:buNone/>
-            </a:pPr>
-            <a:r>
-              <a:rPr lang="en-US" sz="1300" dirty="0">
-                <a:solidFill>
-                  <a:srgbClr val="15131A"/>
-                </a:solidFill>
-                <a:latin typeface="Pretendard" pitchFamily="34" charset="0"/>
-                <a:ea typeface="Pretendard" pitchFamily="34" charset="-122"/>
-                <a:cs typeface="Pretendard" pitchFamily="34" charset="-120"/>
-              </a:rPr>
-              <a:t>county loop, conformance-tested, with</a:t>
-            </a:r>
-            <a:endParaRPr lang="en-US" sz="1300" dirty="0"/>
-          </a:p>
-          <a:p>
-            <a:pPr algn="l" indent="0" marL="0">
-              <a:lnSpc>
-                <a:spcPts val="1630"/>
-              </a:lnSpc>
-              <a:buNone/>
-            </a:pPr>
-            <a:r>
-              <a:rPr lang="en-US" sz="1300" dirty="0">
-                <a:solidFill>
-                  <a:srgbClr val="15131A"/>
-                </a:solidFill>
-                <a:latin typeface="Pretendard" pitchFamily="34" charset="0"/>
-                <a:ea typeface="Pretendard" pitchFamily="34" charset="-122"/>
-                <a:cs typeface="Pretendard" pitchFamily="34" charset="-120"/>
-              </a:rPr>
-              <a:t>0 tokens saved on current</a:t>
-            </a:r>
-            <a:endParaRPr lang="en-US" sz="1300" dirty="0"/>
-          </a:p>
-          <a:p>
-            <a:pPr algn="l" indent="0" marL="0">
-              <a:lnSpc>
-                <a:spcPts val="1630"/>
-              </a:lnSpc>
-              <a:buNone/>
-            </a:pPr>
-            <a:r>
-              <a:rPr lang="en-US" sz="1300" dirty="0">
-                <a:solidFill>
-                  <a:srgbClr val="15131A"/>
-                </a:solidFill>
-                <a:latin typeface="Pretendard" pitchFamily="34" charset="0"/>
-                <a:ea typeface="Pretendard" pitchFamily="34" charset="-122"/>
-                <a:cs typeface="Pretendard" pitchFamily="34" charset="-120"/>
-              </a:rPr>
-              <a:t>single-chunk sources.</a:t>
-            </a:r>
-            <a:endParaRPr lang="en-US" sz="1300" dirty="0"/>
-          </a:p>
         </p:txBody>
       </p:sp>
       <p:sp>
@@ -12052,7 +11850,7 @@
         </p:nvSpPr>
         <p:spPr>
           <a:xfrm>
-            <a:off x="8229600" y="5414963"/>
+            <a:off x="304800" y="5108893"/>
             <a:ext cx="50800" cy="50800"/>
           </a:xfrm>
           <a:prstGeom prst="rect">
@@ -12072,8 +11870,8 @@
         </p:nvSpPr>
         <p:spPr>
           <a:xfrm>
-            <a:off x="8407400" y="5337175"/>
-            <a:ext cx="3479800" cy="206375"/>
+            <a:off x="482600" y="5031105"/>
+            <a:ext cx="8432800" cy="206375"/>
           </a:xfrm>
           <a:prstGeom prst="rect">
             <a:avLst/>
@@ -12100,7 +11898,7 @@
                 <a:ea typeface="Pretendard" pitchFamily="34" charset="-122"/>
                 <a:cs typeface="Pretendard" pitchFamily="34" charset="-120"/>
               </a:rPr>
-              <a:t>Cursor: &lt;to confirm&gt;</a:t>
+              <a:t>Cursor: Dockerfile written in a Cursor Agent CLI session (30d5b90); rest built with Claude Code.</a:t>
             </a:r>
             <a:endParaRPr lang="en-US" sz="1300" dirty="0"/>
           </a:p>

</xml_diff>